<commit_message>
refactor(slides): replace text-only left panel with a flow architecture diagram
Co-authored-by: Congying Zhang <JasonZhangcy@users.noreply.github.com>
</commit_message>
<xml_diff>
--- a/slides/codearts-agent-team-obp.pptx
+++ b/slides/codearts-agent-team-obp.pptx
@@ -3472,16 +3472,105 @@
         </p:nvSpPr>
         <p:spPr>
           <a:xfrm>
-            <a:off x="384048" y="1572768"/>
-            <a:ext cx="5175504" cy="804672"/>
+            <a:off x="384048" y="2121408"/>
+            <a:ext cx="932688" cy="2798064"/>
           </a:xfrm>
           <a:prstGeom prst="roundRect">
             <a:avLst>
-              <a:gd name="adj" fmla="val 5500"/>
+              <a:gd name="adj" fmla="val 6000"/>
             </a:avLst>
           </a:prstGeom>
           <a:solidFill>
-            <a:srgbClr val="F6F8FB"/>
+            <a:srgbClr val="EDF7F6"/>
+          </a:solidFill>
+          <a:ln w="9525">
+            <a:solidFill>
+              <a:srgbClr val="0F9B8E"/>
+            </a:solidFill>
+          </a:ln>
+          <a:effectLst/>
+        </p:spPr>
+        <p:style>
+          <a:lnRef idx="1">
+            <a:schemeClr val="accent1"/>
+          </a:lnRef>
+          <a:fillRef idx="3">
+            <a:schemeClr val="accent1"/>
+          </a:fillRef>
+          <a:effectRef idx="2">
+            <a:schemeClr val="accent1"/>
+          </a:effectRef>
+          <a:fontRef idx="minor">
+            <a:schemeClr val="lt1"/>
+          </a:fontRef>
+        </p:style>
+        <p:txBody>
+          <a:bodyPr rtlCol="0" anchor="ctr" wrap="square"/>
+          <a:lstStyle/>
+          <a:p>
+            <a:pPr algn="ctr"/>
+          </a:p>
+        </p:txBody>
+      </p:sp>
+      <p:sp>
+        <p:nvSpPr>
+          <p:cNvPr id="12" name="TextBox 11"/>
+          <p:cNvSpPr txBox="1"/>
+          <p:nvPr/>
+        </p:nvSpPr>
+        <p:spPr>
+          <a:xfrm>
+            <a:off x="429768" y="2203703"/>
+            <a:ext cx="841248" cy="310896"/>
+          </a:xfrm>
+          <a:prstGeom prst="rect">
+            <a:avLst/>
+          </a:prstGeom>
+          <a:noFill/>
+        </p:spPr>
+        <p:txBody>
+          <a:bodyPr wrap="square" lIns="0" rIns="0" tIns="0" bIns="0" anchor="t">
+            <a:spAutoFit/>
+          </a:bodyPr>
+          <a:lstStyle/>
+          <a:p>
+            <a:pPr algn="ctr">
+              <a:lnSpc>
+                <a:spcPct val="110000"/>
+              </a:lnSpc>
+            </a:pPr>
+            <a:r>
+              <a:rPr sz="800" b="1">
+                <a:solidFill>
+                  <a:srgbClr val="0F9B8E"/>
+                </a:solidFill>
+                <a:latin typeface="Arial"/>
+                <a:ea typeface="微软雅黑"/>
+              </a:rPr>
+              <a:t>专家 / 专家团
+资产库</a:t>
+            </a:r>
+          </a:p>
+        </p:txBody>
+      </p:sp>
+      <p:sp>
+        <p:nvSpPr>
+          <p:cNvPr id="13" name="Rounded Rectangle 12"/>
+          <p:cNvSpPr/>
+          <p:nvPr/>
+        </p:nvSpPr>
+        <p:spPr>
+          <a:xfrm>
+            <a:off x="448056" y="2560320"/>
+            <a:ext cx="804672" cy="365760"/>
+          </a:xfrm>
+          <a:prstGeom prst="roundRect">
+            <a:avLst>
+              <a:gd name="adj" fmla="val 14000"/>
+            </a:avLst>
+          </a:prstGeom>
+          <a:solidFill>
+            <a:srgbClr val="FFFFFF"/>
           </a:solidFill>
           <a:ln w="9525">
             <a:solidFill>
@@ -3505,93 +3594,23 @@
           </a:fontRef>
         </p:style>
         <p:txBody>
-          <a:bodyPr rtlCol="0" anchor="ctr" wrap="square"/>
-          <a:lstStyle/>
-          <a:p>
-            <a:pPr algn="ctr"/>
-          </a:p>
-        </p:txBody>
-      </p:sp>
-      <p:sp>
-        <p:nvSpPr>
-          <p:cNvPr id="12" name="Rectangle 11"/>
-          <p:cNvSpPr/>
-          <p:nvPr/>
-        </p:nvSpPr>
-        <p:spPr>
-          <a:xfrm>
-            <a:off x="434340" y="1641348"/>
-            <a:ext cx="68580" cy="667512"/>
-          </a:xfrm>
-          <a:prstGeom prst="rect">
-            <a:avLst/>
-          </a:prstGeom>
-          <a:solidFill>
-            <a:srgbClr val="2E6BE6"/>
-          </a:solidFill>
-          <a:ln>
-            <a:noFill/>
-          </a:ln>
-          <a:effectLst/>
-        </p:spPr>
-        <p:style>
-          <a:lnRef idx="1">
-            <a:schemeClr val="accent1"/>
-          </a:lnRef>
-          <a:fillRef idx="3">
-            <a:schemeClr val="accent1"/>
-          </a:fillRef>
-          <a:effectRef idx="2">
-            <a:schemeClr val="accent1"/>
-          </a:effectRef>
-          <a:fontRef idx="minor">
-            <a:schemeClr val="lt1"/>
-          </a:fontRef>
-        </p:style>
-        <p:txBody>
-          <a:bodyPr rtlCol="0" anchor="ctr" wrap="square"/>
-          <a:lstStyle/>
-          <a:p>
-            <a:pPr algn="ctr"/>
-          </a:p>
-        </p:txBody>
-      </p:sp>
-      <p:sp>
-        <p:nvSpPr>
-          <p:cNvPr id="13" name="TextBox 12"/>
-          <p:cNvSpPr txBox="1"/>
-          <p:nvPr/>
-        </p:nvSpPr>
-        <p:spPr>
-          <a:xfrm>
-            <a:off x="603503" y="1664208"/>
-            <a:ext cx="4370831" cy="237744"/>
-          </a:xfrm>
-          <a:prstGeom prst="rect">
-            <a:avLst/>
-          </a:prstGeom>
-          <a:noFill/>
-        </p:spPr>
-        <p:txBody>
-          <a:bodyPr wrap="square" lIns="0" rIns="0" tIns="0" bIns="0" anchor="t">
-            <a:spAutoFit/>
-          </a:bodyPr>
-          <a:lstStyle/>
-          <a:p>
-            <a:pPr algn="l">
+          <a:bodyPr rtlCol="0" anchor="ctr" wrap="square" lIns="27432" rIns="27432" tIns="0" bIns="0"/>
+          <a:lstStyle/>
+          <a:p>
+            <a:pPr algn="ctr">
               <a:lnSpc>
-                <a:spcPct val="95000"/>
+                <a:spcPct val="105000"/>
               </a:lnSpc>
             </a:pPr>
             <a:r>
-              <a:rPr sz="1150" b="1">
+              <a:rPr sz="700" b="0">
                 <a:solidFill>
                   <a:srgbClr val="14213D"/>
                 </a:solidFill>
                 <a:latin typeface="Arial"/>
                 <a:ea typeface="微软雅黑"/>
               </a:rPr>
-              <a:t>① 统一入口 One Entry</a:t>
+              <a:t>Role Profile</a:t>
             </a:r>
           </a:p>
         </p:txBody>
@@ -3604,12 +3623,659 @@
         </p:nvSpPr>
         <p:spPr>
           <a:xfrm>
-            <a:off x="5029200" y="1677924"/>
-            <a:ext cx="402336" cy="196596"/>
+            <a:off x="448056" y="3044952"/>
+            <a:ext cx="804672" cy="365760"/>
           </a:xfrm>
           <a:prstGeom prst="roundRect">
             <a:avLst>
-              <a:gd name="adj" fmla="val 28000"/>
+              <a:gd name="adj" fmla="val 14000"/>
+            </a:avLst>
+          </a:prstGeom>
+          <a:solidFill>
+            <a:srgbClr val="FFFFFF"/>
+          </a:solidFill>
+          <a:ln w="9525">
+            <a:solidFill>
+              <a:srgbClr val="D9E0EA"/>
+            </a:solidFill>
+          </a:ln>
+          <a:effectLst/>
+        </p:spPr>
+        <p:style>
+          <a:lnRef idx="1">
+            <a:schemeClr val="accent1"/>
+          </a:lnRef>
+          <a:fillRef idx="3">
+            <a:schemeClr val="accent1"/>
+          </a:fillRef>
+          <a:effectRef idx="2">
+            <a:schemeClr val="accent1"/>
+          </a:effectRef>
+          <a:fontRef idx="minor">
+            <a:schemeClr val="lt1"/>
+          </a:fontRef>
+        </p:style>
+        <p:txBody>
+          <a:bodyPr rtlCol="0" anchor="ctr" wrap="square" lIns="27432" rIns="27432" tIns="0" bIns="0"/>
+          <a:lstStyle/>
+          <a:p>
+            <a:pPr algn="ctr">
+              <a:lnSpc>
+                <a:spcPct val="105000"/>
+              </a:lnSpc>
+            </a:pPr>
+            <a:r>
+              <a:rPr sz="700" b="0">
+                <a:solidFill>
+                  <a:srgbClr val="14213D"/>
+                </a:solidFill>
+                <a:latin typeface="Arial"/>
+                <a:ea typeface="微软雅黑"/>
+              </a:rPr>
+              <a:t>Blueprint 三态</a:t>
+            </a:r>
+          </a:p>
+        </p:txBody>
+      </p:sp>
+      <p:sp>
+        <p:nvSpPr>
+          <p:cNvPr id="15" name="Rounded Rectangle 14"/>
+          <p:cNvSpPr/>
+          <p:nvPr/>
+        </p:nvSpPr>
+        <p:spPr>
+          <a:xfrm>
+            <a:off x="448056" y="3529584"/>
+            <a:ext cx="804672" cy="365760"/>
+          </a:xfrm>
+          <a:prstGeom prst="roundRect">
+            <a:avLst>
+              <a:gd name="adj" fmla="val 14000"/>
+            </a:avLst>
+          </a:prstGeom>
+          <a:solidFill>
+            <a:srgbClr val="FFFFFF"/>
+          </a:solidFill>
+          <a:ln w="9525">
+            <a:solidFill>
+              <a:srgbClr val="D9E0EA"/>
+            </a:solidFill>
+          </a:ln>
+          <a:effectLst/>
+        </p:spPr>
+        <p:style>
+          <a:lnRef idx="1">
+            <a:schemeClr val="accent1"/>
+          </a:lnRef>
+          <a:fillRef idx="3">
+            <a:schemeClr val="accent1"/>
+          </a:fillRef>
+          <a:effectRef idx="2">
+            <a:schemeClr val="accent1"/>
+          </a:effectRef>
+          <a:fontRef idx="minor">
+            <a:schemeClr val="lt1"/>
+          </a:fontRef>
+        </p:style>
+        <p:txBody>
+          <a:bodyPr rtlCol="0" anchor="ctr" wrap="square" lIns="27432" rIns="27432" tIns="0" bIns="0"/>
+          <a:lstStyle/>
+          <a:p>
+            <a:pPr algn="ctr">
+              <a:lnSpc>
+                <a:spcPct val="105000"/>
+              </a:lnSpc>
+            </a:pPr>
+            <a:r>
+              <a:rPr sz="700" b="0">
+                <a:solidFill>
+                  <a:srgbClr val="14213D"/>
+                </a:solidFill>
+                <a:latin typeface="Arial"/>
+                <a:ea typeface="微软雅黑"/>
+              </a:rPr>
+              <a:t>场景专家团包</a:t>
+            </a:r>
+          </a:p>
+        </p:txBody>
+      </p:sp>
+      <p:sp>
+        <p:nvSpPr>
+          <p:cNvPr id="16" name="Rounded Rectangle 15"/>
+          <p:cNvSpPr/>
+          <p:nvPr/>
+        </p:nvSpPr>
+        <p:spPr>
+          <a:xfrm>
+            <a:off x="448056" y="4014215"/>
+            <a:ext cx="804672" cy="365760"/>
+          </a:xfrm>
+          <a:prstGeom prst="roundRect">
+            <a:avLst>
+              <a:gd name="adj" fmla="val 14000"/>
+            </a:avLst>
+          </a:prstGeom>
+          <a:solidFill>
+            <a:srgbClr val="FFFFFF"/>
+          </a:solidFill>
+          <a:ln w="9525">
+            <a:solidFill>
+              <a:srgbClr val="D9E0EA"/>
+            </a:solidFill>
+          </a:ln>
+          <a:effectLst/>
+        </p:spPr>
+        <p:style>
+          <a:lnRef idx="1">
+            <a:schemeClr val="accent1"/>
+          </a:lnRef>
+          <a:fillRef idx="3">
+            <a:schemeClr val="accent1"/>
+          </a:fillRef>
+          <a:effectRef idx="2">
+            <a:schemeClr val="accent1"/>
+          </a:effectRef>
+          <a:fontRef idx="minor">
+            <a:schemeClr val="lt1"/>
+          </a:fontRef>
+        </p:style>
+        <p:txBody>
+          <a:bodyPr rtlCol="0" anchor="ctr" wrap="square" lIns="27432" rIns="27432" tIns="0" bIns="0"/>
+          <a:lstStyle/>
+          <a:p>
+            <a:pPr algn="ctr">
+              <a:lnSpc>
+                <a:spcPct val="105000"/>
+              </a:lnSpc>
+            </a:pPr>
+            <a:r>
+              <a:rPr sz="700" b="0">
+                <a:solidFill>
+                  <a:srgbClr val="14213D"/>
+                </a:solidFill>
+                <a:latin typeface="Arial"/>
+                <a:ea typeface="微软雅黑"/>
+              </a:rPr>
+              <a:t>市场·分级治理</a:t>
+            </a:r>
+          </a:p>
+        </p:txBody>
+      </p:sp>
+      <p:sp>
+        <p:nvSpPr>
+          <p:cNvPr id="17" name="Rounded Rectangle 16"/>
+          <p:cNvSpPr/>
+          <p:nvPr/>
+        </p:nvSpPr>
+        <p:spPr>
+          <a:xfrm>
+            <a:off x="448056" y="4498848"/>
+            <a:ext cx="804672" cy="365760"/>
+          </a:xfrm>
+          <a:prstGeom prst="roundRect">
+            <a:avLst>
+              <a:gd name="adj" fmla="val 14000"/>
+            </a:avLst>
+          </a:prstGeom>
+          <a:solidFill>
+            <a:srgbClr val="FFFFFF"/>
+          </a:solidFill>
+          <a:ln w="9525">
+            <a:solidFill>
+              <a:srgbClr val="D9E0EA"/>
+            </a:solidFill>
+          </a:ln>
+          <a:effectLst/>
+        </p:spPr>
+        <p:style>
+          <a:lnRef idx="1">
+            <a:schemeClr val="accent1"/>
+          </a:lnRef>
+          <a:fillRef idx="3">
+            <a:schemeClr val="accent1"/>
+          </a:fillRef>
+          <a:effectRef idx="2">
+            <a:schemeClr val="accent1"/>
+          </a:effectRef>
+          <a:fontRef idx="minor">
+            <a:schemeClr val="lt1"/>
+          </a:fontRef>
+        </p:style>
+        <p:txBody>
+          <a:bodyPr rtlCol="0" anchor="ctr" wrap="square" lIns="27432" rIns="27432" tIns="0" bIns="0"/>
+          <a:lstStyle/>
+          <a:p>
+            <a:pPr algn="ctr">
+              <a:lnSpc>
+                <a:spcPct val="105000"/>
+              </a:lnSpc>
+            </a:pPr>
+            <a:r>
+              <a:rPr sz="700" b="0">
+                <a:solidFill>
+                  <a:srgbClr val="14213D"/>
+                </a:solidFill>
+                <a:latin typeface="Arial"/>
+                <a:ea typeface="微软雅黑"/>
+              </a:rPr>
+              <a:t>Codebase 注入</a:t>
+            </a:r>
+          </a:p>
+        </p:txBody>
+      </p:sp>
+      <p:sp>
+        <p:nvSpPr>
+          <p:cNvPr id="18" name="Rounded Rectangle 17"/>
+          <p:cNvSpPr/>
+          <p:nvPr/>
+        </p:nvSpPr>
+        <p:spPr>
+          <a:xfrm>
+            <a:off x="4626864" y="2121408"/>
+            <a:ext cx="932688" cy="2798064"/>
+          </a:xfrm>
+          <a:prstGeom prst="roundRect">
+            <a:avLst>
+              <a:gd name="adj" fmla="val 6000"/>
+            </a:avLst>
+          </a:prstGeom>
+          <a:solidFill>
+            <a:srgbClr val="F2F4F7"/>
+          </a:solidFill>
+          <a:ln w="9525">
+            <a:solidFill>
+              <a:srgbClr val="4A5568"/>
+            </a:solidFill>
+          </a:ln>
+          <a:effectLst/>
+        </p:spPr>
+        <p:style>
+          <a:lnRef idx="1">
+            <a:schemeClr val="accent1"/>
+          </a:lnRef>
+          <a:fillRef idx="3">
+            <a:schemeClr val="accent1"/>
+          </a:fillRef>
+          <a:effectRef idx="2">
+            <a:schemeClr val="accent1"/>
+          </a:effectRef>
+          <a:fontRef idx="minor">
+            <a:schemeClr val="lt1"/>
+          </a:fontRef>
+        </p:style>
+        <p:txBody>
+          <a:bodyPr rtlCol="0" anchor="ctr" wrap="square"/>
+          <a:lstStyle/>
+          <a:p>
+            <a:pPr algn="ctr"/>
+          </a:p>
+        </p:txBody>
+      </p:sp>
+      <p:sp>
+        <p:nvSpPr>
+          <p:cNvPr id="19" name="TextBox 18"/>
+          <p:cNvSpPr txBox="1"/>
+          <p:nvPr/>
+        </p:nvSpPr>
+        <p:spPr>
+          <a:xfrm>
+            <a:off x="4672584" y="2203703"/>
+            <a:ext cx="841248" cy="310896"/>
+          </a:xfrm>
+          <a:prstGeom prst="rect">
+            <a:avLst/>
+          </a:prstGeom>
+          <a:noFill/>
+        </p:spPr>
+        <p:txBody>
+          <a:bodyPr wrap="square" lIns="0" rIns="0" tIns="0" bIns="0" anchor="t">
+            <a:spAutoFit/>
+          </a:bodyPr>
+          <a:lstStyle/>
+          <a:p>
+            <a:pPr algn="ctr">
+              <a:lnSpc>
+                <a:spcPct val="110000"/>
+              </a:lnSpc>
+            </a:pPr>
+            <a:r>
+              <a:rPr sz="800" b="1">
+                <a:solidFill>
+                  <a:srgbClr val="4A5568"/>
+                </a:solidFill>
+                <a:latin typeface="Arial"/>
+                <a:ea typeface="微软雅黑"/>
+              </a:rPr>
+              <a:t>Agent Team Ops
+底座</a:t>
+            </a:r>
+          </a:p>
+        </p:txBody>
+      </p:sp>
+      <p:sp>
+        <p:nvSpPr>
+          <p:cNvPr id="20" name="Rounded Rectangle 19"/>
+          <p:cNvSpPr/>
+          <p:nvPr/>
+        </p:nvSpPr>
+        <p:spPr>
+          <a:xfrm>
+            <a:off x="4690872" y="2560320"/>
+            <a:ext cx="804672" cy="365760"/>
+          </a:xfrm>
+          <a:prstGeom prst="roundRect">
+            <a:avLst>
+              <a:gd name="adj" fmla="val 14000"/>
+            </a:avLst>
+          </a:prstGeom>
+          <a:solidFill>
+            <a:srgbClr val="FFFFFF"/>
+          </a:solidFill>
+          <a:ln w="9525">
+            <a:solidFill>
+              <a:srgbClr val="D9E0EA"/>
+            </a:solidFill>
+          </a:ln>
+          <a:effectLst/>
+        </p:spPr>
+        <p:style>
+          <a:lnRef idx="1">
+            <a:schemeClr val="accent1"/>
+          </a:lnRef>
+          <a:fillRef idx="3">
+            <a:schemeClr val="accent1"/>
+          </a:fillRef>
+          <a:effectRef idx="2">
+            <a:schemeClr val="accent1"/>
+          </a:effectRef>
+          <a:fontRef idx="minor">
+            <a:schemeClr val="lt1"/>
+          </a:fontRef>
+        </p:style>
+        <p:txBody>
+          <a:bodyPr rtlCol="0" anchor="ctr" wrap="square" lIns="27432" rIns="27432" tIns="0" bIns="0"/>
+          <a:lstStyle/>
+          <a:p>
+            <a:pPr algn="ctr">
+              <a:lnSpc>
+                <a:spcPct val="105000"/>
+              </a:lnSpc>
+            </a:pPr>
+            <a:r>
+              <a:rPr sz="700" b="0">
+                <a:solidFill>
+                  <a:srgbClr val="14213D"/>
+                </a:solidFill>
+                <a:latin typeface="Arial"/>
+                <a:ea typeface="微软雅黑"/>
+              </a:rPr>
+              <a:t>记忆·轨迹复盘</a:t>
+            </a:r>
+          </a:p>
+        </p:txBody>
+      </p:sp>
+      <p:sp>
+        <p:nvSpPr>
+          <p:cNvPr id="21" name="Rounded Rectangle 20"/>
+          <p:cNvSpPr/>
+          <p:nvPr/>
+        </p:nvSpPr>
+        <p:spPr>
+          <a:xfrm>
+            <a:off x="4690872" y="3044952"/>
+            <a:ext cx="804672" cy="365760"/>
+          </a:xfrm>
+          <a:prstGeom prst="roundRect">
+            <a:avLst>
+              <a:gd name="adj" fmla="val 14000"/>
+            </a:avLst>
+          </a:prstGeom>
+          <a:solidFill>
+            <a:srgbClr val="FFFFFF"/>
+          </a:solidFill>
+          <a:ln w="9525">
+            <a:solidFill>
+              <a:srgbClr val="D9E0EA"/>
+            </a:solidFill>
+          </a:ln>
+          <a:effectLst/>
+        </p:spPr>
+        <p:style>
+          <a:lnRef idx="1">
+            <a:schemeClr val="accent1"/>
+          </a:lnRef>
+          <a:fillRef idx="3">
+            <a:schemeClr val="accent1"/>
+          </a:fillRef>
+          <a:effectRef idx="2">
+            <a:schemeClr val="accent1"/>
+          </a:effectRef>
+          <a:fontRef idx="minor">
+            <a:schemeClr val="lt1"/>
+          </a:fontRef>
+        </p:style>
+        <p:txBody>
+          <a:bodyPr rtlCol="0" anchor="ctr" wrap="square" lIns="27432" rIns="27432" tIns="0" bIns="0"/>
+          <a:lstStyle/>
+          <a:p>
+            <a:pPr algn="ctr">
+              <a:lnSpc>
+                <a:spcPct val="105000"/>
+              </a:lnSpc>
+            </a:pPr>
+            <a:r>
+              <a:rPr sz="700" b="0">
+                <a:solidFill>
+                  <a:srgbClr val="14213D"/>
+                </a:solidFill>
+                <a:latin typeface="Arial"/>
+                <a:ea typeface="微软雅黑"/>
+              </a:rPr>
+              <a:t>沙箱·单线程</a:t>
+            </a:r>
+          </a:p>
+        </p:txBody>
+      </p:sp>
+      <p:sp>
+        <p:nvSpPr>
+          <p:cNvPr id="22" name="Rounded Rectangle 21"/>
+          <p:cNvSpPr/>
+          <p:nvPr/>
+        </p:nvSpPr>
+        <p:spPr>
+          <a:xfrm>
+            <a:off x="4690872" y="3529584"/>
+            <a:ext cx="804672" cy="365760"/>
+          </a:xfrm>
+          <a:prstGeom prst="roundRect">
+            <a:avLst>
+              <a:gd name="adj" fmla="val 14000"/>
+            </a:avLst>
+          </a:prstGeom>
+          <a:solidFill>
+            <a:srgbClr val="FFFFFF"/>
+          </a:solidFill>
+          <a:ln w="9525">
+            <a:solidFill>
+              <a:srgbClr val="D9E0EA"/>
+            </a:solidFill>
+          </a:ln>
+          <a:effectLst/>
+        </p:spPr>
+        <p:style>
+          <a:lnRef idx="1">
+            <a:schemeClr val="accent1"/>
+          </a:lnRef>
+          <a:fillRef idx="3">
+            <a:schemeClr val="accent1"/>
+          </a:fillRef>
+          <a:effectRef idx="2">
+            <a:schemeClr val="accent1"/>
+          </a:effectRef>
+          <a:fontRef idx="minor">
+            <a:schemeClr val="lt1"/>
+          </a:fontRef>
+        </p:style>
+        <p:txBody>
+          <a:bodyPr rtlCol="0" anchor="ctr" wrap="square" lIns="27432" rIns="27432" tIns="0" bIns="0"/>
+          <a:lstStyle/>
+          <a:p>
+            <a:pPr algn="ctr">
+              <a:lnSpc>
+                <a:spcPct val="105000"/>
+              </a:lnSpc>
+            </a:pPr>
+            <a:r>
+              <a:rPr sz="700" b="0">
+                <a:solidFill>
+                  <a:srgbClr val="14213D"/>
+                </a:solidFill>
+                <a:latin typeface="Arial"/>
+                <a:ea typeface="微软雅黑"/>
+              </a:rPr>
+              <a:t>预算·配额·熔断</a:t>
+            </a:r>
+          </a:p>
+        </p:txBody>
+      </p:sp>
+      <p:sp>
+        <p:nvSpPr>
+          <p:cNvPr id="23" name="Rounded Rectangle 22"/>
+          <p:cNvSpPr/>
+          <p:nvPr/>
+        </p:nvSpPr>
+        <p:spPr>
+          <a:xfrm>
+            <a:off x="4690872" y="4014215"/>
+            <a:ext cx="804672" cy="365760"/>
+          </a:xfrm>
+          <a:prstGeom prst="roundRect">
+            <a:avLst>
+              <a:gd name="adj" fmla="val 14000"/>
+            </a:avLst>
+          </a:prstGeom>
+          <a:solidFill>
+            <a:srgbClr val="FFFFFF"/>
+          </a:solidFill>
+          <a:ln w="9525">
+            <a:solidFill>
+              <a:srgbClr val="D9E0EA"/>
+            </a:solidFill>
+          </a:ln>
+          <a:effectLst/>
+        </p:spPr>
+        <p:style>
+          <a:lnRef idx="1">
+            <a:schemeClr val="accent1"/>
+          </a:lnRef>
+          <a:fillRef idx="3">
+            <a:schemeClr val="accent1"/>
+          </a:fillRef>
+          <a:effectRef idx="2">
+            <a:schemeClr val="accent1"/>
+          </a:effectRef>
+          <a:fontRef idx="minor">
+            <a:schemeClr val="lt1"/>
+          </a:fontRef>
+        </p:style>
+        <p:txBody>
+          <a:bodyPr rtlCol="0" anchor="ctr" wrap="square" lIns="27432" rIns="27432" tIns="0" bIns="0"/>
+          <a:lstStyle/>
+          <a:p>
+            <a:pPr algn="ctr">
+              <a:lnSpc>
+                <a:spcPct val="105000"/>
+              </a:lnSpc>
+            </a:pPr>
+            <a:r>
+              <a:rPr sz="700" b="0">
+                <a:solidFill>
+                  <a:srgbClr val="14213D"/>
+                </a:solidFill>
+                <a:latin typeface="Arial"/>
+                <a:ea typeface="微软雅黑"/>
+              </a:rPr>
+              <a:t>审计·权限治理</a:t>
+            </a:r>
+          </a:p>
+        </p:txBody>
+      </p:sp>
+      <p:sp>
+        <p:nvSpPr>
+          <p:cNvPr id="24" name="Rounded Rectangle 23"/>
+          <p:cNvSpPr/>
+          <p:nvPr/>
+        </p:nvSpPr>
+        <p:spPr>
+          <a:xfrm>
+            <a:off x="4690872" y="4498848"/>
+            <a:ext cx="804672" cy="365760"/>
+          </a:xfrm>
+          <a:prstGeom prst="roundRect">
+            <a:avLst>
+              <a:gd name="adj" fmla="val 14000"/>
+            </a:avLst>
+          </a:prstGeom>
+          <a:solidFill>
+            <a:srgbClr val="FFFFFF"/>
+          </a:solidFill>
+          <a:ln w="9525">
+            <a:solidFill>
+              <a:srgbClr val="D9E0EA"/>
+            </a:solidFill>
+          </a:ln>
+          <a:effectLst/>
+        </p:spPr>
+        <p:style>
+          <a:lnRef idx="1">
+            <a:schemeClr val="accent1"/>
+          </a:lnRef>
+          <a:fillRef idx="3">
+            <a:schemeClr val="accent1"/>
+          </a:fillRef>
+          <a:effectRef idx="2">
+            <a:schemeClr val="accent1"/>
+          </a:effectRef>
+          <a:fontRef idx="minor">
+            <a:schemeClr val="lt1"/>
+          </a:fontRef>
+        </p:style>
+        <p:txBody>
+          <a:bodyPr rtlCol="0" anchor="ctr" wrap="square" lIns="27432" rIns="27432" tIns="0" bIns="0"/>
+          <a:lstStyle/>
+          <a:p>
+            <a:pPr algn="ctr">
+              <a:lnSpc>
+                <a:spcPct val="105000"/>
+              </a:lnSpc>
+            </a:pPr>
+            <a:r>
+              <a:rPr sz="700" b="0">
+                <a:solidFill>
+                  <a:srgbClr val="14213D"/>
+                </a:solidFill>
+                <a:latin typeface="Arial"/>
+                <a:ea typeface="微软雅黑"/>
+              </a:rPr>
+              <a:t>可观测大盘</a:t>
+            </a:r>
+          </a:p>
+        </p:txBody>
+      </p:sp>
+      <p:sp>
+        <p:nvSpPr>
+          <p:cNvPr id="25" name="Rounded Rectangle 24"/>
+          <p:cNvSpPr/>
+          <p:nvPr/>
+        </p:nvSpPr>
+        <p:spPr>
+          <a:xfrm>
+            <a:off x="1801367" y="1572768"/>
+            <a:ext cx="2340864" cy="384048"/>
+          </a:xfrm>
+          <a:prstGeom prst="roundRect">
+            <a:avLst>
+              <a:gd name="adj" fmla="val 36000"/>
             </a:avLst>
           </a:prstGeom>
           <a:solidFill>
@@ -3635,109 +4301,60 @@
           </a:fontRef>
         </p:style>
         <p:txBody>
-          <a:bodyPr rtlCol="0" anchor="ctr" wrap="square"/>
-          <a:lstStyle/>
-          <a:p>
-            <a:pPr algn="ctr"/>
-          </a:p>
-        </p:txBody>
-      </p:sp>
-      <p:sp>
-        <p:nvSpPr>
-          <p:cNvPr id="15" name="TextBox 14"/>
-          <p:cNvSpPr txBox="1"/>
-          <p:nvPr/>
-        </p:nvSpPr>
-        <p:spPr>
-          <a:xfrm>
-            <a:off x="5029200" y="1705356"/>
-            <a:ext cx="402336" cy="164592"/>
-          </a:xfrm>
-          <a:prstGeom prst="rect">
-            <a:avLst/>
-          </a:prstGeom>
-          <a:noFill/>
-        </p:spPr>
-        <p:txBody>
-          <a:bodyPr wrap="square" lIns="0" rIns="0" tIns="0" bIns="0" anchor="t">
-            <a:spAutoFit/>
-          </a:bodyPr>
+          <a:bodyPr rtlCol="0" anchor="ctr" wrap="square" lIns="27432" rIns="27432" tIns="0" bIns="0"/>
           <a:lstStyle/>
           <a:p>
             <a:pPr algn="ctr">
               <a:lnSpc>
-                <a:spcPct val="95000"/>
+                <a:spcPct val="105000"/>
               </a:lnSpc>
             </a:pPr>
             <a:r>
-              <a:rPr sz="800" b="1">
+              <a:rPr sz="950" b="1">
                 <a:solidFill>
                   <a:srgbClr val="FFFFFF"/>
                 </a:solidFill>
                 <a:latin typeface="Arial"/>
                 <a:ea typeface="微软雅黑"/>
               </a:rPr>
-              <a:t>P0</a:t>
-            </a:r>
-          </a:p>
-        </p:txBody>
-      </p:sp>
-      <p:sp>
-        <p:nvSpPr>
-          <p:cNvPr id="16" name="TextBox 15"/>
-          <p:cNvSpPr txBox="1"/>
-          <p:nvPr/>
-        </p:nvSpPr>
-        <p:spPr>
-          <a:xfrm>
-            <a:off x="603503" y="1938528"/>
-            <a:ext cx="4754880" cy="384048"/>
-          </a:xfrm>
-          <a:prstGeom prst="rect">
-            <a:avLst/>
-          </a:prstGeom>
-          <a:noFill/>
-        </p:spPr>
-        <p:txBody>
-          <a:bodyPr wrap="square" lIns="0" rIns="0" tIns="0" bIns="0" anchor="t">
-            <a:spAutoFit/>
-          </a:bodyPr>
-          <a:lstStyle/>
-          <a:p>
-            <a:pPr algn="l">
+              <a:t>① 统一入口 One Entry</a:t>
+            </a:r>
+          </a:p>
+          <a:p>
+            <a:pPr algn="ctr">
               <a:lnSpc>
-                <a:spcPct val="116000"/>
+                <a:spcPct val="105000"/>
               </a:lnSpc>
             </a:pPr>
             <a:r>
-              <a:rPr sz="850" b="0">
+              <a:rPr sz="700" b="0">
                 <a:solidFill>
-                  <a:srgbClr val="5A6678"/>
+                  <a:srgbClr val="FFFFFF"/>
                 </a:solidFill>
                 <a:latin typeface="Arial"/>
                 <a:ea typeface="微软雅黑"/>
               </a:rPr>
-              <a:t>任务描述单一入口进入，IDE / Agent Space / CLI / 流水线多端接入；发起时不再由人选择单 Agent 或 Agent Team</a:t>
-            </a:r>
-          </a:p>
-        </p:txBody>
-      </p:sp>
-      <p:sp>
-        <p:nvSpPr>
-          <p:cNvPr id="17" name="Isosceles Triangle 16"/>
+              <a:t>自然语言任务 / 专家召唤 · IDE · CLI · 流水线</a:t>
+            </a:r>
+          </a:p>
+        </p:txBody>
+      </p:sp>
+      <p:sp>
+        <p:nvSpPr>
+          <p:cNvPr id="26" name="Down Arrow 25"/>
           <p:cNvSpPr/>
           <p:nvPr/>
         </p:nvSpPr>
         <p:spPr>
-          <a:xfrm rot="10800000">
-            <a:off x="2843784" y="2386584"/>
-            <a:ext cx="256032" cy="137160"/>
-          </a:xfrm>
-          <a:prstGeom prst="triangle">
+          <a:xfrm>
+            <a:off x="2903220" y="1975104"/>
+            <a:ext cx="137160" cy="128016"/>
+          </a:xfrm>
+          <a:prstGeom prst="downArrow">
             <a:avLst/>
           </a:prstGeom>
           <a:solidFill>
-            <a:srgbClr val="8C9AAD"/>
+            <a:srgbClr val="6B7A90"/>
           </a:solidFill>
           <a:ln>
             <a:noFill/>
@@ -3768,18 +4385,18 @@
       </p:sp>
       <p:sp>
         <p:nvSpPr>
-          <p:cNvPr id="18" name="Rounded Rectangle 17"/>
+          <p:cNvPr id="27" name="Rounded Rectangle 26"/>
           <p:cNvSpPr/>
           <p:nvPr/>
         </p:nvSpPr>
         <p:spPr>
           <a:xfrm>
-            <a:off x="384048" y="2532887"/>
-            <a:ext cx="5175504" cy="804672"/>
+            <a:off x="1481328" y="2121408"/>
+            <a:ext cx="2980944" cy="402336"/>
           </a:xfrm>
           <a:prstGeom prst="roundRect">
             <a:avLst>
-              <a:gd name="adj" fmla="val 5500"/>
+              <a:gd name="adj" fmla="val 14000"/>
             </a:avLst>
           </a:prstGeom>
           <a:solidFill>
@@ -3807,111 +4424,103 @@
           </a:fontRef>
         </p:style>
         <p:txBody>
-          <a:bodyPr rtlCol="0" anchor="ctr" wrap="square"/>
-          <a:lstStyle/>
-          <a:p>
-            <a:pPr algn="ctr"/>
-          </a:p>
-        </p:txBody>
-      </p:sp>
-      <p:sp>
-        <p:nvSpPr>
-          <p:cNvPr id="19" name="Rectangle 18"/>
-          <p:cNvSpPr/>
-          <p:nvPr/>
-        </p:nvSpPr>
-        <p:spPr>
-          <a:xfrm>
-            <a:off x="434340" y="2601468"/>
-            <a:ext cx="68580" cy="667512"/>
-          </a:xfrm>
-          <a:prstGeom prst="rect">
-            <a:avLst/>
-          </a:prstGeom>
-          <a:solidFill>
-            <a:srgbClr val="C7000B"/>
-          </a:solidFill>
-          <a:ln>
-            <a:noFill/>
-          </a:ln>
-          <a:effectLst/>
-        </p:spPr>
-        <p:style>
-          <a:lnRef idx="1">
-            <a:schemeClr val="accent1"/>
-          </a:lnRef>
-          <a:fillRef idx="3">
-            <a:schemeClr val="accent1"/>
-          </a:fillRef>
-          <a:effectRef idx="2">
-            <a:schemeClr val="accent1"/>
-          </a:effectRef>
-          <a:fontRef idx="minor">
-            <a:schemeClr val="lt1"/>
-          </a:fontRef>
-        </p:style>
-        <p:txBody>
-          <a:bodyPr rtlCol="0" anchor="ctr" wrap="square"/>
-          <a:lstStyle/>
-          <a:p>
-            <a:pPr algn="ctr"/>
-          </a:p>
-        </p:txBody>
-      </p:sp>
-      <p:sp>
-        <p:nvSpPr>
-          <p:cNvPr id="20" name="TextBox 19"/>
-          <p:cNvSpPr txBox="1"/>
-          <p:nvPr/>
-        </p:nvSpPr>
-        <p:spPr>
-          <a:xfrm>
-            <a:off x="603503" y="2624327"/>
-            <a:ext cx="3547872" cy="237744"/>
-          </a:xfrm>
-          <a:prstGeom prst="rect">
-            <a:avLst/>
-          </a:prstGeom>
-          <a:noFill/>
-        </p:spPr>
-        <p:txBody>
-          <a:bodyPr wrap="square" lIns="0" rIns="0" tIns="0" bIns="0" anchor="t">
-            <a:spAutoFit/>
-          </a:bodyPr>
-          <a:lstStyle/>
-          <a:p>
-            <a:pPr algn="l">
+          <a:bodyPr rtlCol="0" anchor="ctr" wrap="square" lIns="27432" rIns="27432" tIns="0" bIns="0"/>
+          <a:lstStyle/>
+          <a:p>
+            <a:pPr algn="ctr">
               <a:lnSpc>
-                <a:spcPct val="95000"/>
+                <a:spcPct val="105000"/>
               </a:lnSpc>
             </a:pPr>
             <a:r>
-              <a:rPr sz="1150" b="1">
+              <a:rPr sz="950" b="1">
                 <a:solidFill>
                   <a:srgbClr val="C7000B"/>
                 </a:solidFill>
                 <a:latin typeface="Arial"/>
                 <a:ea typeface="微软雅黑"/>
               </a:rPr>
-              <a:t>② 决策层 · 编排形态自主路由</a:t>
-            </a:r>
-          </a:p>
-        </p:txBody>
-      </p:sp>
-      <p:sp>
-        <p:nvSpPr>
-          <p:cNvPr id="21" name="Rounded Rectangle 20"/>
+              <a:t>② 任务复杂度画像</a:t>
+            </a:r>
+          </a:p>
+          <a:p>
+            <a:pPr algn="ctr">
+              <a:lnSpc>
+                <a:spcPct val="105000"/>
+              </a:lnSpc>
+            </a:pPr>
+            <a:r>
+              <a:rPr sz="700" b="0">
+                <a:solidFill>
+                  <a:srgbClr val="5A6678"/>
+                </a:solidFill>
+                <a:latin typeface="Arial"/>
+                <a:ea typeface="微软雅黑"/>
+              </a:rPr>
+              <a:t>任务信号 · 仓库耦合信号 · 可并行度 · 历史表现</a:t>
+            </a:r>
+          </a:p>
+        </p:txBody>
+      </p:sp>
+      <p:sp>
+        <p:nvSpPr>
+          <p:cNvPr id="28" name="Down Arrow 27"/>
           <p:cNvSpPr/>
           <p:nvPr/>
         </p:nvSpPr>
         <p:spPr>
           <a:xfrm>
-            <a:off x="4206240" y="2638044"/>
-            <a:ext cx="1225296" cy="196596"/>
-          </a:xfrm>
-          <a:prstGeom prst="roundRect">
+            <a:off x="2903220" y="2542032"/>
+            <a:ext cx="137160" cy="128016"/>
+          </a:xfrm>
+          <a:prstGeom prst="downArrow">
+            <a:avLst/>
+          </a:prstGeom>
+          <a:solidFill>
+            <a:srgbClr val="6B7A90"/>
+          </a:solidFill>
+          <a:ln>
+            <a:noFill/>
+          </a:ln>
+          <a:effectLst/>
+        </p:spPr>
+        <p:style>
+          <a:lnRef idx="1">
+            <a:schemeClr val="accent1"/>
+          </a:lnRef>
+          <a:fillRef idx="3">
+            <a:schemeClr val="accent1"/>
+          </a:fillRef>
+          <a:effectRef idx="2">
+            <a:schemeClr val="accent1"/>
+          </a:effectRef>
+          <a:fontRef idx="minor">
+            <a:schemeClr val="lt1"/>
+          </a:fontRef>
+        </p:style>
+        <p:txBody>
+          <a:bodyPr rtlCol="0" anchor="ctr" wrap="square"/>
+          <a:lstStyle/>
+          <a:p>
+            <a:pPr algn="ctr"/>
+          </a:p>
+        </p:txBody>
+      </p:sp>
+      <p:sp>
+        <p:nvSpPr>
+          <p:cNvPr id="29" name="Hexagon 28"/>
+          <p:cNvSpPr/>
+          <p:nvPr/>
+        </p:nvSpPr>
+        <p:spPr>
+          <a:xfrm>
+            <a:off x="1481328" y="2688336"/>
+            <a:ext cx="2980944" cy="457200"/>
+          </a:xfrm>
+          <a:prstGeom prst="hexagon">
             <a:avLst>
-              <a:gd name="adj" fmla="val 28000"/>
+              <a:gd name="adj" fmla="val 10000"/>
+              <a:gd name="vf" fmla="val 115470"/>
             </a:avLst>
           </a:prstGeom>
           <a:solidFill>
@@ -3937,109 +4546,60 @@
           </a:fontRef>
         </p:style>
         <p:txBody>
-          <a:bodyPr rtlCol="0" anchor="ctr" wrap="square"/>
-          <a:lstStyle/>
-          <a:p>
-            <a:pPr algn="ctr"/>
-          </a:p>
-        </p:txBody>
-      </p:sp>
-      <p:sp>
-        <p:nvSpPr>
-          <p:cNvPr id="22" name="TextBox 21"/>
-          <p:cNvSpPr txBox="1"/>
-          <p:nvPr/>
-        </p:nvSpPr>
-        <p:spPr>
-          <a:xfrm>
-            <a:off x="4206240" y="2665475"/>
-            <a:ext cx="1225296" cy="164592"/>
-          </a:xfrm>
-          <a:prstGeom prst="rect">
-            <a:avLst/>
-          </a:prstGeom>
-          <a:noFill/>
-        </p:spPr>
-        <p:txBody>
-          <a:bodyPr wrap="square" lIns="0" rIns="0" tIns="0" bIns="0" anchor="t">
-            <a:spAutoFit/>
-          </a:bodyPr>
+          <a:bodyPr rtlCol="0" anchor="ctr" wrap="square" lIns="27432" rIns="27432" tIns="0" bIns="0"/>
           <a:lstStyle/>
           <a:p>
             <a:pPr algn="ctr">
               <a:lnSpc>
-                <a:spcPct val="95000"/>
+                <a:spcPct val="105000"/>
               </a:lnSpc>
             </a:pPr>
             <a:r>
-              <a:rPr sz="800" b="1">
+              <a:rPr sz="1000" b="1">
                 <a:solidFill>
                   <a:srgbClr val="FFFFFF"/>
                 </a:solidFill>
                 <a:latin typeface="Arial"/>
                 <a:ea typeface="微软雅黑"/>
               </a:rPr>
-              <a:t>P0 · L3 业界空白</a:t>
-            </a:r>
-          </a:p>
-        </p:txBody>
-      </p:sp>
-      <p:sp>
-        <p:nvSpPr>
-          <p:cNvPr id="23" name="TextBox 22"/>
-          <p:cNvSpPr txBox="1"/>
-          <p:nvPr/>
-        </p:nvSpPr>
-        <p:spPr>
-          <a:xfrm>
-            <a:off x="603503" y="2898647"/>
-            <a:ext cx="4754880" cy="384048"/>
-          </a:xfrm>
-          <a:prstGeom prst="rect">
-            <a:avLst/>
-          </a:prstGeom>
-          <a:noFill/>
-        </p:spPr>
-        <p:txBody>
-          <a:bodyPr wrap="square" lIns="0" rIns="0" tIns="0" bIns="0" anchor="t">
-            <a:spAutoFit/>
-          </a:bodyPr>
-          <a:lstStyle/>
-          <a:p>
-            <a:pPr algn="l">
+              <a:t>③ 编排策略引擎  ·  形态自主路由</a:t>
+            </a:r>
+          </a:p>
+          <a:p>
+            <a:pPr algn="ctr">
               <a:lnSpc>
-                <a:spcPct val="116000"/>
+                <a:spcPct val="105000"/>
               </a:lnSpc>
             </a:pPr>
             <a:r>
-              <a:rPr sz="850" b="0">
+              <a:rPr sz="700" b="0">
                 <a:solidFill>
-                  <a:srgbClr val="5A6678"/>
+                  <a:srgbClr val="FFFFFF"/>
                 </a:solidFill>
                 <a:latin typeface="Arial"/>
                 <a:ea typeface="微软雅黑"/>
               </a:rPr>
-              <a:t>复杂度画像（任务信号 + 仓库耦合信号）→ 策略引擎决策形态·规模·模型档位·预算；升配降配断点续跑、路由可解释与 Pin、预算熔断</a:t>
-            </a:r>
-          </a:p>
-        </p:txBody>
-      </p:sp>
-      <p:sp>
-        <p:nvSpPr>
-          <p:cNvPr id="24" name="Isosceles Triangle 23"/>
+              <a:t>形态 · 规模 · 模型档位 · 预算    ｜    L3 业界空白</a:t>
+            </a:r>
+          </a:p>
+        </p:txBody>
+      </p:sp>
+      <p:sp>
+        <p:nvSpPr>
+          <p:cNvPr id="30" name="Rectangle 29"/>
           <p:cNvSpPr/>
           <p:nvPr/>
         </p:nvSpPr>
         <p:spPr>
-          <a:xfrm rot="10800000">
-            <a:off x="2843784" y="3346703"/>
-            <a:ext cx="256032" cy="137160"/>
-          </a:xfrm>
-          <a:prstGeom prst="triangle">
+          <a:xfrm>
+            <a:off x="2971800" y="3145536"/>
+            <a:ext cx="11430" cy="54864"/>
+          </a:xfrm>
+          <a:prstGeom prst="rect">
             <a:avLst/>
           </a:prstGeom>
           <a:solidFill>
-            <a:srgbClr val="8C9AAD"/>
+            <a:srgbClr val="6B7A90"/>
           </a:solidFill>
           <a:ln>
             <a:noFill/>
@@ -4070,22 +4630,154 @@
       </p:sp>
       <p:sp>
         <p:nvSpPr>
-          <p:cNvPr id="25" name="Rounded Rectangle 24"/>
+          <p:cNvPr id="31" name="Rectangle 30"/>
           <p:cNvSpPr/>
           <p:nvPr/>
         </p:nvSpPr>
         <p:spPr>
           <a:xfrm>
-            <a:off x="384048" y="3493007"/>
-            <a:ext cx="5175504" cy="804672"/>
+            <a:off x="1947672" y="3200400"/>
+            <a:ext cx="2048256" cy="11430"/>
+          </a:xfrm>
+          <a:prstGeom prst="rect">
+            <a:avLst/>
+          </a:prstGeom>
+          <a:solidFill>
+            <a:srgbClr val="6B7A90"/>
+          </a:solidFill>
+          <a:ln>
+            <a:noFill/>
+          </a:ln>
+          <a:effectLst/>
+        </p:spPr>
+        <p:style>
+          <a:lnRef idx="1">
+            <a:schemeClr val="accent1"/>
+          </a:lnRef>
+          <a:fillRef idx="3">
+            <a:schemeClr val="accent1"/>
+          </a:fillRef>
+          <a:effectRef idx="2">
+            <a:schemeClr val="accent1"/>
+          </a:effectRef>
+          <a:fontRef idx="minor">
+            <a:schemeClr val="lt1"/>
+          </a:fontRef>
+        </p:style>
+        <p:txBody>
+          <a:bodyPr rtlCol="0" anchor="ctr" wrap="square"/>
+          <a:lstStyle/>
+          <a:p>
+            <a:pPr algn="ctr"/>
+          </a:p>
+        </p:txBody>
+      </p:sp>
+      <p:sp>
+        <p:nvSpPr>
+          <p:cNvPr id="32" name="Rectangle 31"/>
+          <p:cNvSpPr/>
+          <p:nvPr/>
+        </p:nvSpPr>
+        <p:spPr>
+          <a:xfrm>
+            <a:off x="1947672" y="3200400"/>
+            <a:ext cx="11430" cy="54864"/>
+          </a:xfrm>
+          <a:prstGeom prst="rect">
+            <a:avLst/>
+          </a:prstGeom>
+          <a:solidFill>
+            <a:srgbClr val="6B7A90"/>
+          </a:solidFill>
+          <a:ln>
+            <a:noFill/>
+          </a:ln>
+          <a:effectLst/>
+        </p:spPr>
+        <p:style>
+          <a:lnRef idx="1">
+            <a:schemeClr val="accent1"/>
+          </a:lnRef>
+          <a:fillRef idx="3">
+            <a:schemeClr val="accent1"/>
+          </a:fillRef>
+          <a:effectRef idx="2">
+            <a:schemeClr val="accent1"/>
+          </a:effectRef>
+          <a:fontRef idx="minor">
+            <a:schemeClr val="lt1"/>
+          </a:fontRef>
+        </p:style>
+        <p:txBody>
+          <a:bodyPr rtlCol="0" anchor="ctr" wrap="square"/>
+          <a:lstStyle/>
+          <a:p>
+            <a:pPr algn="ctr"/>
+          </a:p>
+        </p:txBody>
+      </p:sp>
+      <p:sp>
+        <p:nvSpPr>
+          <p:cNvPr id="33" name="Down Arrow 32"/>
+          <p:cNvSpPr/>
+          <p:nvPr/>
+        </p:nvSpPr>
+        <p:spPr>
+          <a:xfrm>
+            <a:off x="1892807" y="3200400"/>
+            <a:ext cx="109728" cy="91440"/>
+          </a:xfrm>
+          <a:prstGeom prst="downArrow">
+            <a:avLst/>
+          </a:prstGeom>
+          <a:solidFill>
+            <a:srgbClr val="6B7A90"/>
+          </a:solidFill>
+          <a:ln>
+            <a:noFill/>
+          </a:ln>
+          <a:effectLst/>
+        </p:spPr>
+        <p:style>
+          <a:lnRef idx="1">
+            <a:schemeClr val="accent1"/>
+          </a:lnRef>
+          <a:fillRef idx="3">
+            <a:schemeClr val="accent1"/>
+          </a:fillRef>
+          <a:effectRef idx="2">
+            <a:schemeClr val="accent1"/>
+          </a:effectRef>
+          <a:fontRef idx="minor">
+            <a:schemeClr val="lt1"/>
+          </a:fontRef>
+        </p:style>
+        <p:txBody>
+          <a:bodyPr rtlCol="0" anchor="ctr" wrap="square"/>
+          <a:lstStyle/>
+          <a:p>
+            <a:pPr algn="ctr"/>
+          </a:p>
+        </p:txBody>
+      </p:sp>
+      <p:sp>
+        <p:nvSpPr>
+          <p:cNvPr id="34" name="Rounded Rectangle 33"/>
+          <p:cNvSpPr/>
+          <p:nvPr/>
+        </p:nvSpPr>
+        <p:spPr>
+          <a:xfrm>
+            <a:off x="1481328" y="3291840"/>
+            <a:ext cx="932688" cy="347472"/>
           </a:xfrm>
           <a:prstGeom prst="roundRect">
             <a:avLst>
-              <a:gd name="adj" fmla="val 5500"/>
+              <a:gd name="adj" fmla="val 18000"/>
             </a:avLst>
           </a:prstGeom>
           <a:solidFill>
-            <a:srgbClr val="F6F8FB"/>
+            <a:srgbClr val="FFFFFF"/>
           </a:solidFill>
           <a:ln w="9525">
             <a:solidFill>
@@ -4109,23 +4801,571 @@
           </a:fontRef>
         </p:style>
         <p:txBody>
-          <a:bodyPr rtlCol="0" anchor="ctr" wrap="square"/>
-          <a:lstStyle/>
-          <a:p>
-            <a:pPr algn="ctr"/>
-          </a:p>
-        </p:txBody>
-      </p:sp>
-      <p:sp>
-        <p:nvSpPr>
-          <p:cNvPr id="26" name="Rectangle 25"/>
+          <a:bodyPr rtlCol="0" anchor="ctr" wrap="square" lIns="27432" rIns="27432" tIns="0" bIns="0"/>
+          <a:lstStyle/>
+          <a:p>
+            <a:pPr algn="ctr">
+              <a:lnSpc>
+                <a:spcPct val="105000"/>
+              </a:lnSpc>
+            </a:pPr>
+            <a:r>
+              <a:rPr sz="800" b="1">
+                <a:solidFill>
+                  <a:srgbClr val="14213D"/>
+                </a:solidFill>
+                <a:latin typeface="Arial"/>
+                <a:ea typeface="微软雅黑"/>
+              </a:rPr>
+              <a:t>单 Agent</a:t>
+            </a:r>
+          </a:p>
+        </p:txBody>
+      </p:sp>
+      <p:sp>
+        <p:nvSpPr>
+          <p:cNvPr id="35" name="Rectangle 34"/>
           <p:cNvSpPr/>
           <p:nvPr/>
         </p:nvSpPr>
         <p:spPr>
           <a:xfrm>
-            <a:off x="434340" y="3561587"/>
-            <a:ext cx="68580" cy="667512"/>
+            <a:off x="2971800" y="3200400"/>
+            <a:ext cx="11430" cy="54864"/>
+          </a:xfrm>
+          <a:prstGeom prst="rect">
+            <a:avLst/>
+          </a:prstGeom>
+          <a:solidFill>
+            <a:srgbClr val="6B7A90"/>
+          </a:solidFill>
+          <a:ln>
+            <a:noFill/>
+          </a:ln>
+          <a:effectLst/>
+        </p:spPr>
+        <p:style>
+          <a:lnRef idx="1">
+            <a:schemeClr val="accent1"/>
+          </a:lnRef>
+          <a:fillRef idx="3">
+            <a:schemeClr val="accent1"/>
+          </a:fillRef>
+          <a:effectRef idx="2">
+            <a:schemeClr val="accent1"/>
+          </a:effectRef>
+          <a:fontRef idx="minor">
+            <a:schemeClr val="lt1"/>
+          </a:fontRef>
+        </p:style>
+        <p:txBody>
+          <a:bodyPr rtlCol="0" anchor="ctr" wrap="square"/>
+          <a:lstStyle/>
+          <a:p>
+            <a:pPr algn="ctr"/>
+          </a:p>
+        </p:txBody>
+      </p:sp>
+      <p:sp>
+        <p:nvSpPr>
+          <p:cNvPr id="36" name="Down Arrow 35"/>
+          <p:cNvSpPr/>
+          <p:nvPr/>
+        </p:nvSpPr>
+        <p:spPr>
+          <a:xfrm>
+            <a:off x="2916936" y="3200400"/>
+            <a:ext cx="109728" cy="91440"/>
+          </a:xfrm>
+          <a:prstGeom prst="downArrow">
+            <a:avLst/>
+          </a:prstGeom>
+          <a:solidFill>
+            <a:srgbClr val="6B7A90"/>
+          </a:solidFill>
+          <a:ln>
+            <a:noFill/>
+          </a:ln>
+          <a:effectLst/>
+        </p:spPr>
+        <p:style>
+          <a:lnRef idx="1">
+            <a:schemeClr val="accent1"/>
+          </a:lnRef>
+          <a:fillRef idx="3">
+            <a:schemeClr val="accent1"/>
+          </a:fillRef>
+          <a:effectRef idx="2">
+            <a:schemeClr val="accent1"/>
+          </a:effectRef>
+          <a:fontRef idx="minor">
+            <a:schemeClr val="lt1"/>
+          </a:fontRef>
+        </p:style>
+        <p:txBody>
+          <a:bodyPr rtlCol="0" anchor="ctr" wrap="square"/>
+          <a:lstStyle/>
+          <a:p>
+            <a:pPr algn="ctr"/>
+          </a:p>
+        </p:txBody>
+      </p:sp>
+      <p:sp>
+        <p:nvSpPr>
+          <p:cNvPr id="37" name="Rounded Rectangle 36"/>
+          <p:cNvSpPr/>
+          <p:nvPr/>
+        </p:nvSpPr>
+        <p:spPr>
+          <a:xfrm>
+            <a:off x="2505456" y="3291840"/>
+            <a:ext cx="932688" cy="347472"/>
+          </a:xfrm>
+          <a:prstGeom prst="roundRect">
+            <a:avLst>
+              <a:gd name="adj" fmla="val 18000"/>
+            </a:avLst>
+          </a:prstGeom>
+          <a:solidFill>
+            <a:srgbClr val="FFFFFF"/>
+          </a:solidFill>
+          <a:ln w="9525">
+            <a:solidFill>
+              <a:srgbClr val="D9E0EA"/>
+            </a:solidFill>
+          </a:ln>
+          <a:effectLst/>
+        </p:spPr>
+        <p:style>
+          <a:lnRef idx="1">
+            <a:schemeClr val="accent1"/>
+          </a:lnRef>
+          <a:fillRef idx="3">
+            <a:schemeClr val="accent1"/>
+          </a:fillRef>
+          <a:effectRef idx="2">
+            <a:schemeClr val="accent1"/>
+          </a:effectRef>
+          <a:fontRef idx="minor">
+            <a:schemeClr val="lt1"/>
+          </a:fontRef>
+        </p:style>
+        <p:txBody>
+          <a:bodyPr rtlCol="0" anchor="ctr" wrap="square" lIns="27432" rIns="27432" tIns="0" bIns="0"/>
+          <a:lstStyle/>
+          <a:p>
+            <a:pPr algn="ctr">
+              <a:lnSpc>
+                <a:spcPct val="105000"/>
+              </a:lnSpc>
+            </a:pPr>
+            <a:r>
+              <a:rPr sz="800" b="1">
+                <a:solidFill>
+                  <a:srgbClr val="14213D"/>
+                </a:solidFill>
+                <a:latin typeface="Arial"/>
+                <a:ea typeface="微软雅黑"/>
+              </a:rPr>
+              <a:t>单 Agent + 评审</a:t>
+            </a:r>
+          </a:p>
+        </p:txBody>
+      </p:sp>
+      <p:sp>
+        <p:nvSpPr>
+          <p:cNvPr id="38" name="Rectangle 37"/>
+          <p:cNvSpPr/>
+          <p:nvPr/>
+        </p:nvSpPr>
+        <p:spPr>
+          <a:xfrm>
+            <a:off x="3995928" y="3200400"/>
+            <a:ext cx="11430" cy="54864"/>
+          </a:xfrm>
+          <a:prstGeom prst="rect">
+            <a:avLst/>
+          </a:prstGeom>
+          <a:solidFill>
+            <a:srgbClr val="6B7A90"/>
+          </a:solidFill>
+          <a:ln>
+            <a:noFill/>
+          </a:ln>
+          <a:effectLst/>
+        </p:spPr>
+        <p:style>
+          <a:lnRef idx="1">
+            <a:schemeClr val="accent1"/>
+          </a:lnRef>
+          <a:fillRef idx="3">
+            <a:schemeClr val="accent1"/>
+          </a:fillRef>
+          <a:effectRef idx="2">
+            <a:schemeClr val="accent1"/>
+          </a:effectRef>
+          <a:fontRef idx="minor">
+            <a:schemeClr val="lt1"/>
+          </a:fontRef>
+        </p:style>
+        <p:txBody>
+          <a:bodyPr rtlCol="0" anchor="ctr" wrap="square"/>
+          <a:lstStyle/>
+          <a:p>
+            <a:pPr algn="ctr"/>
+          </a:p>
+        </p:txBody>
+      </p:sp>
+      <p:sp>
+        <p:nvSpPr>
+          <p:cNvPr id="39" name="Down Arrow 38"/>
+          <p:cNvSpPr/>
+          <p:nvPr/>
+        </p:nvSpPr>
+        <p:spPr>
+          <a:xfrm>
+            <a:off x="3941064" y="3200400"/>
+            <a:ext cx="109728" cy="91440"/>
+          </a:xfrm>
+          <a:prstGeom prst="downArrow">
+            <a:avLst/>
+          </a:prstGeom>
+          <a:solidFill>
+            <a:srgbClr val="6B7A90"/>
+          </a:solidFill>
+          <a:ln>
+            <a:noFill/>
+          </a:ln>
+          <a:effectLst/>
+        </p:spPr>
+        <p:style>
+          <a:lnRef idx="1">
+            <a:schemeClr val="accent1"/>
+          </a:lnRef>
+          <a:fillRef idx="3">
+            <a:schemeClr val="accent1"/>
+          </a:fillRef>
+          <a:effectRef idx="2">
+            <a:schemeClr val="accent1"/>
+          </a:effectRef>
+          <a:fontRef idx="minor">
+            <a:schemeClr val="lt1"/>
+          </a:fontRef>
+        </p:style>
+        <p:txBody>
+          <a:bodyPr rtlCol="0" anchor="ctr" wrap="square"/>
+          <a:lstStyle/>
+          <a:p>
+            <a:pPr algn="ctr"/>
+          </a:p>
+        </p:txBody>
+      </p:sp>
+      <p:sp>
+        <p:nvSpPr>
+          <p:cNvPr id="40" name="Rounded Rectangle 39"/>
+          <p:cNvSpPr/>
+          <p:nvPr/>
+        </p:nvSpPr>
+        <p:spPr>
+          <a:xfrm>
+            <a:off x="3529584" y="3291840"/>
+            <a:ext cx="932688" cy="347472"/>
+          </a:xfrm>
+          <a:prstGeom prst="roundRect">
+            <a:avLst>
+              <a:gd name="adj" fmla="val 18000"/>
+            </a:avLst>
+          </a:prstGeom>
+          <a:solidFill>
+            <a:srgbClr val="F4EFFB"/>
+          </a:solidFill>
+          <a:ln w="9525">
+            <a:solidFill>
+              <a:srgbClr val="7A3EBF"/>
+            </a:solidFill>
+          </a:ln>
+          <a:effectLst/>
+        </p:spPr>
+        <p:style>
+          <a:lnRef idx="1">
+            <a:schemeClr val="accent1"/>
+          </a:lnRef>
+          <a:fillRef idx="3">
+            <a:schemeClr val="accent1"/>
+          </a:fillRef>
+          <a:effectRef idx="2">
+            <a:schemeClr val="accent1"/>
+          </a:effectRef>
+          <a:fontRef idx="minor">
+            <a:schemeClr val="lt1"/>
+          </a:fontRef>
+        </p:style>
+        <p:txBody>
+          <a:bodyPr rtlCol="0" anchor="ctr" wrap="square" lIns="27432" rIns="27432" tIns="0" bIns="0"/>
+          <a:lstStyle/>
+          <a:p>
+            <a:pPr algn="ctr">
+              <a:lnSpc>
+                <a:spcPct val="105000"/>
+              </a:lnSpc>
+            </a:pPr>
+            <a:r>
+              <a:rPr sz="800" b="1">
+                <a:solidFill>
+                  <a:srgbClr val="7A3EBF"/>
+                </a:solidFill>
+                <a:latin typeface="Arial"/>
+                <a:ea typeface="微软雅黑"/>
+              </a:rPr>
+              <a:t>Agent Team</a:t>
+            </a:r>
+          </a:p>
+        </p:txBody>
+      </p:sp>
+      <p:sp>
+        <p:nvSpPr>
+          <p:cNvPr id="41" name="Left-Right Arrow 40"/>
+          <p:cNvSpPr/>
+          <p:nvPr/>
+        </p:nvSpPr>
+        <p:spPr>
+          <a:xfrm>
+            <a:off x="1947672" y="3694176"/>
+            <a:ext cx="2048256" cy="146304"/>
+          </a:xfrm>
+          <a:prstGeom prst="leftRightArrow">
+            <a:avLst/>
+          </a:prstGeom>
+          <a:solidFill>
+            <a:srgbClr val="F4EFFB"/>
+          </a:solidFill>
+          <a:ln w="9525">
+            <a:solidFill>
+              <a:srgbClr val="7A3EBF"/>
+            </a:solidFill>
+          </a:ln>
+          <a:effectLst/>
+        </p:spPr>
+        <p:style>
+          <a:lnRef idx="1">
+            <a:schemeClr val="accent1"/>
+          </a:lnRef>
+          <a:fillRef idx="3">
+            <a:schemeClr val="accent1"/>
+          </a:fillRef>
+          <a:effectRef idx="2">
+            <a:schemeClr val="accent1"/>
+          </a:effectRef>
+          <a:fontRef idx="minor">
+            <a:schemeClr val="lt1"/>
+          </a:fontRef>
+        </p:style>
+        <p:txBody>
+          <a:bodyPr rtlCol="0" anchor="ctr" wrap="square"/>
+          <a:lstStyle/>
+          <a:p>
+            <a:pPr algn="ctr"/>
+          </a:p>
+        </p:txBody>
+      </p:sp>
+      <p:sp>
+        <p:nvSpPr>
+          <p:cNvPr id="42" name="TextBox 41"/>
+          <p:cNvSpPr txBox="1"/>
+          <p:nvPr/>
+        </p:nvSpPr>
+        <p:spPr>
+          <a:xfrm>
+            <a:off x="1481328" y="3858768"/>
+            <a:ext cx="2980944" cy="146304"/>
+          </a:xfrm>
+          <a:prstGeom prst="rect">
+            <a:avLst/>
+          </a:prstGeom>
+          <a:noFill/>
+        </p:spPr>
+        <p:txBody>
+          <a:bodyPr wrap="square" lIns="0" rIns="0" tIns="0" bIns="0" anchor="t">
+            <a:spAutoFit/>
+          </a:bodyPr>
+          <a:lstStyle/>
+          <a:p>
+            <a:pPr algn="ctr">
+              <a:lnSpc>
+                <a:spcPct val="95000"/>
+              </a:lnSpc>
+            </a:pPr>
+            <a:r>
+              <a:rPr sz="700" b="0">
+                <a:solidFill>
+                  <a:srgbClr val="7A3EBF"/>
+                </a:solidFill>
+                <a:latin typeface="Arial"/>
+                <a:ea typeface="微软雅黑"/>
+              </a:rPr>
+              <a:t>升配 / 降配 · checkpoint 续跑（不重启）</a:t>
+            </a:r>
+          </a:p>
+        </p:txBody>
+      </p:sp>
+      <p:sp>
+        <p:nvSpPr>
+          <p:cNvPr id="43" name="Rounded Rectangle 42"/>
+          <p:cNvSpPr/>
+          <p:nvPr/>
+        </p:nvSpPr>
+        <p:spPr>
+          <a:xfrm>
+            <a:off x="1481328" y="4041648"/>
+            <a:ext cx="2980944" cy="914400"/>
+          </a:xfrm>
+          <a:prstGeom prst="roundRect">
+            <a:avLst>
+              <a:gd name="adj" fmla="val 8000"/>
+            </a:avLst>
+          </a:prstGeom>
+          <a:solidFill>
+            <a:srgbClr val="F4EFFB"/>
+          </a:solidFill>
+          <a:ln w="9525">
+            <a:solidFill>
+              <a:srgbClr val="7A3EBF"/>
+            </a:solidFill>
+          </a:ln>
+          <a:effectLst/>
+        </p:spPr>
+        <p:style>
+          <a:lnRef idx="1">
+            <a:schemeClr val="accent1"/>
+          </a:lnRef>
+          <a:fillRef idx="3">
+            <a:schemeClr val="accent1"/>
+          </a:fillRef>
+          <a:effectRef idx="2">
+            <a:schemeClr val="accent1"/>
+          </a:effectRef>
+          <a:fontRef idx="minor">
+            <a:schemeClr val="lt1"/>
+          </a:fontRef>
+        </p:style>
+        <p:txBody>
+          <a:bodyPr rtlCol="0" anchor="ctr" wrap="square"/>
+          <a:lstStyle/>
+          <a:p>
+            <a:pPr algn="ctr"/>
+          </a:p>
+        </p:txBody>
+      </p:sp>
+      <p:sp>
+        <p:nvSpPr>
+          <p:cNvPr id="44" name="TextBox 43"/>
+          <p:cNvSpPr txBox="1"/>
+          <p:nvPr/>
+        </p:nvSpPr>
+        <p:spPr>
+          <a:xfrm>
+            <a:off x="1572768" y="4087368"/>
+            <a:ext cx="2798064" cy="164592"/>
+          </a:xfrm>
+          <a:prstGeom prst="rect">
+            <a:avLst/>
+          </a:prstGeom>
+          <a:noFill/>
+        </p:spPr>
+        <p:txBody>
+          <a:bodyPr wrap="square" lIns="0" rIns="0" tIns="0" bIns="0" anchor="t">
+            <a:spAutoFit/>
+          </a:bodyPr>
+          <a:lstStyle/>
+          <a:p>
+            <a:pPr algn="l">
+              <a:lnSpc>
+                <a:spcPct val="95000"/>
+              </a:lnSpc>
+            </a:pPr>
+            <a:r>
+              <a:rPr sz="800" b="1">
+                <a:solidFill>
+                  <a:srgbClr val="7A3EBF"/>
+                </a:solidFill>
+                <a:latin typeface="Arial"/>
+                <a:ea typeface="微软雅黑"/>
+              </a:rPr>
+              <a:t>④ Agent Team 执行</a:t>
+            </a:r>
+          </a:p>
+        </p:txBody>
+      </p:sp>
+      <p:sp>
+        <p:nvSpPr>
+          <p:cNvPr id="45" name="Rounded Rectangle 44"/>
+          <p:cNvSpPr/>
+          <p:nvPr/>
+        </p:nvSpPr>
+        <p:spPr>
+          <a:xfrm>
+            <a:off x="2468880" y="4261104"/>
+            <a:ext cx="1005840" cy="201168"/>
+          </a:xfrm>
+          <a:prstGeom prst="roundRect">
+            <a:avLst>
+              <a:gd name="adj" fmla="val 30000"/>
+            </a:avLst>
+          </a:prstGeom>
+          <a:solidFill>
+            <a:srgbClr val="7A3EBF"/>
+          </a:solidFill>
+          <a:ln>
+            <a:noFill/>
+          </a:ln>
+          <a:effectLst/>
+        </p:spPr>
+        <p:style>
+          <a:lnRef idx="1">
+            <a:schemeClr val="accent1"/>
+          </a:lnRef>
+          <a:fillRef idx="3">
+            <a:schemeClr val="accent1"/>
+          </a:fillRef>
+          <a:effectRef idx="2">
+            <a:schemeClr val="accent1"/>
+          </a:effectRef>
+          <a:fontRef idx="minor">
+            <a:schemeClr val="lt1"/>
+          </a:fontRef>
+        </p:style>
+        <p:txBody>
+          <a:bodyPr rtlCol="0" anchor="ctr" wrap="square" lIns="27432" rIns="27432" tIns="0" bIns="0"/>
+          <a:lstStyle/>
+          <a:p>
+            <a:pPr algn="ctr">
+              <a:lnSpc>
+                <a:spcPct val="105000"/>
+              </a:lnSpc>
+            </a:pPr>
+            <a:r>
+              <a:rPr sz="750" b="1">
+                <a:solidFill>
+                  <a:srgbClr val="FFFFFF"/>
+                </a:solidFill>
+                <a:latin typeface="Arial"/>
+                <a:ea typeface="微软雅黑"/>
+              </a:rPr>
+              <a:t>Team Leader</a:t>
+            </a:r>
+          </a:p>
+        </p:txBody>
+      </p:sp>
+      <p:sp>
+        <p:nvSpPr>
+          <p:cNvPr id="46" name="Rectangle 45"/>
+          <p:cNvSpPr/>
+          <p:nvPr/>
+        </p:nvSpPr>
+        <p:spPr>
+          <a:xfrm>
+            <a:off x="2971800" y="4462272"/>
+            <a:ext cx="11430" cy="36576"/>
           </a:xfrm>
           <a:prstGeom prst="rect">
             <a:avLst/>
@@ -4162,59 +5402,17 @@
       </p:sp>
       <p:sp>
         <p:nvSpPr>
-          <p:cNvPr id="27" name="TextBox 26"/>
-          <p:cNvSpPr txBox="1"/>
+          <p:cNvPr id="47" name="Rectangle 46"/>
+          <p:cNvSpPr/>
           <p:nvPr/>
         </p:nvSpPr>
         <p:spPr>
           <a:xfrm>
-            <a:off x="603503" y="3584447"/>
-            <a:ext cx="4059935" cy="237744"/>
+            <a:off x="2002536" y="4498848"/>
+            <a:ext cx="1938528" cy="11430"/>
           </a:xfrm>
           <a:prstGeom prst="rect">
             <a:avLst/>
-          </a:prstGeom>
-          <a:noFill/>
-        </p:spPr>
-        <p:txBody>
-          <a:bodyPr wrap="square" lIns="0" rIns="0" tIns="0" bIns="0" anchor="t">
-            <a:spAutoFit/>
-          </a:bodyPr>
-          <a:lstStyle/>
-          <a:p>
-            <a:pPr algn="l">
-              <a:lnSpc>
-                <a:spcPct val="95000"/>
-              </a:lnSpc>
-            </a:pPr>
-            <a:r>
-              <a:rPr sz="1150" b="1">
-                <a:solidFill>
-                  <a:srgbClr val="14213D"/>
-                </a:solidFill>
-                <a:latin typeface="Arial"/>
-                <a:ea typeface="微软雅黑"/>
-              </a:rPr>
-              <a:t>③ 编排层 · 自主编排与团队资产固化</a:t>
-            </a:r>
-          </a:p>
-        </p:txBody>
-      </p:sp>
-      <p:sp>
-        <p:nvSpPr>
-          <p:cNvPr id="28" name="Rounded Rectangle 27"/>
-          <p:cNvSpPr/>
-          <p:nvPr/>
-        </p:nvSpPr>
-        <p:spPr>
-          <a:xfrm>
-            <a:off x="4718304" y="3598163"/>
-            <a:ext cx="713232" cy="196596"/>
-          </a:xfrm>
-          <a:prstGeom prst="roundRect">
-            <a:avLst>
-              <a:gd name="adj" fmla="val 28000"/>
-            </a:avLst>
           </a:prstGeom>
           <a:solidFill>
             <a:srgbClr val="7A3EBF"/>
@@ -4248,14 +5446,332 @@
       </p:sp>
       <p:sp>
         <p:nvSpPr>
-          <p:cNvPr id="29" name="TextBox 28"/>
+          <p:cNvPr id="48" name="Rectangle 47"/>
+          <p:cNvSpPr/>
+          <p:nvPr/>
+        </p:nvSpPr>
+        <p:spPr>
+          <a:xfrm>
+            <a:off x="2002536" y="4498848"/>
+            <a:ext cx="11430" cy="36576"/>
+          </a:xfrm>
+          <a:prstGeom prst="rect">
+            <a:avLst/>
+          </a:prstGeom>
+          <a:solidFill>
+            <a:srgbClr val="7A3EBF"/>
+          </a:solidFill>
+          <a:ln>
+            <a:noFill/>
+          </a:ln>
+          <a:effectLst/>
+        </p:spPr>
+        <p:style>
+          <a:lnRef idx="1">
+            <a:schemeClr val="accent1"/>
+          </a:lnRef>
+          <a:fillRef idx="3">
+            <a:schemeClr val="accent1"/>
+          </a:fillRef>
+          <a:effectRef idx="2">
+            <a:schemeClr val="accent1"/>
+          </a:effectRef>
+          <a:fontRef idx="minor">
+            <a:schemeClr val="lt1"/>
+          </a:fontRef>
+        </p:style>
+        <p:txBody>
+          <a:bodyPr rtlCol="0" anchor="ctr" wrap="square"/>
+          <a:lstStyle/>
+          <a:p>
+            <a:pPr algn="ctr"/>
+          </a:p>
+        </p:txBody>
+      </p:sp>
+      <p:sp>
+        <p:nvSpPr>
+          <p:cNvPr id="49" name="Rounded Rectangle 48"/>
+          <p:cNvSpPr/>
+          <p:nvPr/>
+        </p:nvSpPr>
+        <p:spPr>
+          <a:xfrm>
+            <a:off x="1591056" y="4535424"/>
+            <a:ext cx="822960" cy="219456"/>
+          </a:xfrm>
+          <a:prstGeom prst="roundRect">
+            <a:avLst>
+              <a:gd name="adj" fmla="val 26000"/>
+            </a:avLst>
+          </a:prstGeom>
+          <a:solidFill>
+            <a:srgbClr val="FFFFFF"/>
+          </a:solidFill>
+          <a:ln w="9525">
+            <a:solidFill>
+              <a:srgbClr val="7A3EBF"/>
+            </a:solidFill>
+          </a:ln>
+          <a:effectLst/>
+        </p:spPr>
+        <p:style>
+          <a:lnRef idx="1">
+            <a:schemeClr val="accent1"/>
+          </a:lnRef>
+          <a:fillRef idx="3">
+            <a:schemeClr val="accent1"/>
+          </a:fillRef>
+          <a:effectRef idx="2">
+            <a:schemeClr val="accent1"/>
+          </a:effectRef>
+          <a:fontRef idx="minor">
+            <a:schemeClr val="lt1"/>
+          </a:fontRef>
+        </p:style>
+        <p:txBody>
+          <a:bodyPr rtlCol="0" anchor="ctr" wrap="square" lIns="27432" rIns="27432" tIns="0" bIns="0"/>
+          <a:lstStyle/>
+          <a:p>
+            <a:pPr algn="ctr">
+              <a:lnSpc>
+                <a:spcPct val="105000"/>
+              </a:lnSpc>
+            </a:pPr>
+            <a:r>
+              <a:rPr sz="700" b="0">
+                <a:solidFill>
+                  <a:srgbClr val="14213D"/>
+                </a:solidFill>
+                <a:latin typeface="Arial"/>
+                <a:ea typeface="微软雅黑"/>
+              </a:rPr>
+              <a:t>Teammate·分析</a:t>
+            </a:r>
+          </a:p>
+        </p:txBody>
+      </p:sp>
+      <p:sp>
+        <p:nvSpPr>
+          <p:cNvPr id="50" name="Rectangle 49"/>
+          <p:cNvSpPr/>
+          <p:nvPr/>
+        </p:nvSpPr>
+        <p:spPr>
+          <a:xfrm>
+            <a:off x="2971800" y="4498848"/>
+            <a:ext cx="11430" cy="36576"/>
+          </a:xfrm>
+          <a:prstGeom prst="rect">
+            <a:avLst/>
+          </a:prstGeom>
+          <a:solidFill>
+            <a:srgbClr val="7A3EBF"/>
+          </a:solidFill>
+          <a:ln>
+            <a:noFill/>
+          </a:ln>
+          <a:effectLst/>
+        </p:spPr>
+        <p:style>
+          <a:lnRef idx="1">
+            <a:schemeClr val="accent1"/>
+          </a:lnRef>
+          <a:fillRef idx="3">
+            <a:schemeClr val="accent1"/>
+          </a:fillRef>
+          <a:effectRef idx="2">
+            <a:schemeClr val="accent1"/>
+          </a:effectRef>
+          <a:fontRef idx="minor">
+            <a:schemeClr val="lt1"/>
+          </a:fontRef>
+        </p:style>
+        <p:txBody>
+          <a:bodyPr rtlCol="0" anchor="ctr" wrap="square"/>
+          <a:lstStyle/>
+          <a:p>
+            <a:pPr algn="ctr"/>
+          </a:p>
+        </p:txBody>
+      </p:sp>
+      <p:sp>
+        <p:nvSpPr>
+          <p:cNvPr id="51" name="Rounded Rectangle 50"/>
+          <p:cNvSpPr/>
+          <p:nvPr/>
+        </p:nvSpPr>
+        <p:spPr>
+          <a:xfrm>
+            <a:off x="2560320" y="4535424"/>
+            <a:ext cx="822960" cy="219456"/>
+          </a:xfrm>
+          <a:prstGeom prst="roundRect">
+            <a:avLst>
+              <a:gd name="adj" fmla="val 26000"/>
+            </a:avLst>
+          </a:prstGeom>
+          <a:solidFill>
+            <a:srgbClr val="FFFFFF"/>
+          </a:solidFill>
+          <a:ln w="9525">
+            <a:solidFill>
+              <a:srgbClr val="7A3EBF"/>
+            </a:solidFill>
+          </a:ln>
+          <a:effectLst/>
+        </p:spPr>
+        <p:style>
+          <a:lnRef idx="1">
+            <a:schemeClr val="accent1"/>
+          </a:lnRef>
+          <a:fillRef idx="3">
+            <a:schemeClr val="accent1"/>
+          </a:fillRef>
+          <a:effectRef idx="2">
+            <a:schemeClr val="accent1"/>
+          </a:effectRef>
+          <a:fontRef idx="minor">
+            <a:schemeClr val="lt1"/>
+          </a:fontRef>
+        </p:style>
+        <p:txBody>
+          <a:bodyPr rtlCol="0" anchor="ctr" wrap="square" lIns="27432" rIns="27432" tIns="0" bIns="0"/>
+          <a:lstStyle/>
+          <a:p>
+            <a:pPr algn="ctr">
+              <a:lnSpc>
+                <a:spcPct val="105000"/>
+              </a:lnSpc>
+            </a:pPr>
+            <a:r>
+              <a:rPr sz="700" b="0">
+                <a:solidFill>
+                  <a:srgbClr val="14213D"/>
+                </a:solidFill>
+                <a:latin typeface="Arial"/>
+                <a:ea typeface="微软雅黑"/>
+              </a:rPr>
+              <a:t>Teammate·开发</a:t>
+            </a:r>
+          </a:p>
+        </p:txBody>
+      </p:sp>
+      <p:sp>
+        <p:nvSpPr>
+          <p:cNvPr id="52" name="Rectangle 51"/>
+          <p:cNvSpPr/>
+          <p:nvPr/>
+        </p:nvSpPr>
+        <p:spPr>
+          <a:xfrm>
+            <a:off x="3941064" y="4498848"/>
+            <a:ext cx="11430" cy="36576"/>
+          </a:xfrm>
+          <a:prstGeom prst="rect">
+            <a:avLst/>
+          </a:prstGeom>
+          <a:solidFill>
+            <a:srgbClr val="7A3EBF"/>
+          </a:solidFill>
+          <a:ln>
+            <a:noFill/>
+          </a:ln>
+          <a:effectLst/>
+        </p:spPr>
+        <p:style>
+          <a:lnRef idx="1">
+            <a:schemeClr val="accent1"/>
+          </a:lnRef>
+          <a:fillRef idx="3">
+            <a:schemeClr val="accent1"/>
+          </a:fillRef>
+          <a:effectRef idx="2">
+            <a:schemeClr val="accent1"/>
+          </a:effectRef>
+          <a:fontRef idx="minor">
+            <a:schemeClr val="lt1"/>
+          </a:fontRef>
+        </p:style>
+        <p:txBody>
+          <a:bodyPr rtlCol="0" anchor="ctr" wrap="square"/>
+          <a:lstStyle/>
+          <a:p>
+            <a:pPr algn="ctr"/>
+          </a:p>
+        </p:txBody>
+      </p:sp>
+      <p:sp>
+        <p:nvSpPr>
+          <p:cNvPr id="53" name="Rounded Rectangle 52"/>
+          <p:cNvSpPr/>
+          <p:nvPr/>
+        </p:nvSpPr>
+        <p:spPr>
+          <a:xfrm>
+            <a:off x="3529584" y="4535424"/>
+            <a:ext cx="822960" cy="219456"/>
+          </a:xfrm>
+          <a:prstGeom prst="roundRect">
+            <a:avLst>
+              <a:gd name="adj" fmla="val 26000"/>
+            </a:avLst>
+          </a:prstGeom>
+          <a:solidFill>
+            <a:srgbClr val="FFFFFF"/>
+          </a:solidFill>
+          <a:ln w="9525">
+            <a:solidFill>
+              <a:srgbClr val="7A3EBF"/>
+            </a:solidFill>
+          </a:ln>
+          <a:effectLst/>
+        </p:spPr>
+        <p:style>
+          <a:lnRef idx="1">
+            <a:schemeClr val="accent1"/>
+          </a:lnRef>
+          <a:fillRef idx="3">
+            <a:schemeClr val="accent1"/>
+          </a:fillRef>
+          <a:effectRef idx="2">
+            <a:schemeClr val="accent1"/>
+          </a:effectRef>
+          <a:fontRef idx="minor">
+            <a:schemeClr val="lt1"/>
+          </a:fontRef>
+        </p:style>
+        <p:txBody>
+          <a:bodyPr rtlCol="0" anchor="ctr" wrap="square" lIns="27432" rIns="27432" tIns="0" bIns="0"/>
+          <a:lstStyle/>
+          <a:p>
+            <a:pPr algn="ctr">
+              <a:lnSpc>
+                <a:spcPct val="105000"/>
+              </a:lnSpc>
+            </a:pPr>
+            <a:r>
+              <a:rPr sz="700" b="0">
+                <a:solidFill>
+                  <a:srgbClr val="14213D"/>
+                </a:solidFill>
+                <a:latin typeface="Arial"/>
+                <a:ea typeface="微软雅黑"/>
+              </a:rPr>
+              <a:t>Teammate·测试</a:t>
+            </a:r>
+          </a:p>
+        </p:txBody>
+      </p:sp>
+      <p:sp>
+        <p:nvSpPr>
+          <p:cNvPr id="54" name="TextBox 53"/>
           <p:cNvSpPr txBox="1"/>
           <p:nvPr/>
         </p:nvSpPr>
         <p:spPr>
           <a:xfrm>
-            <a:off x="4718304" y="3625595"/>
-            <a:ext cx="713232" cy="164592"/>
+            <a:off x="1572768" y="4791456"/>
+            <a:ext cx="2798064" cy="128016"/>
           </a:xfrm>
           <a:prstGeom prst="rect">
             <a:avLst/>
@@ -4274,74 +5790,34 @@
               </a:lnSpc>
             </a:pPr>
             <a:r>
-              <a:rPr sz="800" b="1">
-                <a:solidFill>
-                  <a:srgbClr val="FFFFFF"/>
-                </a:solidFill>
-                <a:latin typeface="Arial"/>
-                <a:ea typeface="微软雅黑"/>
-              </a:rPr>
-              <a:t>P0 · P1</a:t>
-            </a:r>
-          </a:p>
-        </p:txBody>
-      </p:sp>
-      <p:sp>
-        <p:nvSpPr>
-          <p:cNvPr id="30" name="TextBox 29"/>
-          <p:cNvSpPr txBox="1"/>
-          <p:nvPr/>
-        </p:nvSpPr>
-        <p:spPr>
-          <a:xfrm>
-            <a:off x="603503" y="3858768"/>
-            <a:ext cx="4754880" cy="384048"/>
-          </a:xfrm>
-          <a:prstGeom prst="rect">
-            <a:avLst/>
-          </a:prstGeom>
-          <a:noFill/>
-        </p:spPr>
-        <p:txBody>
-          <a:bodyPr wrap="square" lIns="0" rIns="0" tIns="0" bIns="0" anchor="t">
-            <a:spAutoFit/>
-          </a:bodyPr>
-          <a:lstStyle/>
-          <a:p>
-            <a:pPr algn="l">
-              <a:lnSpc>
-                <a:spcPct val="116000"/>
-              </a:lnSpc>
-            </a:pPr>
-            <a:r>
-              <a:rPr sz="850" b="0">
+              <a:rPr sz="650" b="0">
                 <a:solidFill>
                   <a:srgbClr val="5A6678"/>
                 </a:solidFill>
                 <a:latin typeface="Arial"/>
                 <a:ea typeface="微软雅黑"/>
               </a:rPr>
-              <a:t>Team Leader 编排 + Teammate 自主执行 + 共享任务池；Blueprint 三态与版本锁定、参数化槽位、拓扑 DSL 可视化组队、Trace→Blueprint 自动萃取</a:t>
-            </a:r>
-          </a:p>
-        </p:txBody>
-      </p:sp>
-      <p:sp>
-        <p:nvSpPr>
-          <p:cNvPr id="31" name="Isosceles Triangle 30"/>
+              <a:t>共享任务池 · 双向通信 · 写入单线程串行</a:t>
+            </a:r>
+          </a:p>
+        </p:txBody>
+      </p:sp>
+      <p:sp>
+        <p:nvSpPr>
+          <p:cNvPr id="55" name="Down Arrow 54"/>
           <p:cNvSpPr/>
           <p:nvPr/>
         </p:nvSpPr>
         <p:spPr>
-          <a:xfrm rot="10800000">
-            <a:off x="2843784" y="4306823"/>
-            <a:ext cx="256032" cy="137160"/>
-          </a:xfrm>
-          <a:prstGeom prst="triangle">
+          <a:xfrm>
+            <a:off x="2903220" y="4974336"/>
+            <a:ext cx="137160" cy="128016"/>
+          </a:xfrm>
+          <a:prstGeom prst="downArrow">
             <a:avLst/>
           </a:prstGeom>
           <a:solidFill>
-            <a:srgbClr val="8C9AAD"/>
+            <a:srgbClr val="6B7A90"/>
           </a:solidFill>
           <a:ln>
             <a:noFill/>
@@ -4372,26 +5848,26 @@
       </p:sp>
       <p:sp>
         <p:nvSpPr>
-          <p:cNvPr id="32" name="Rounded Rectangle 31"/>
+          <p:cNvPr id="56" name="Rounded Rectangle 55"/>
           <p:cNvSpPr/>
           <p:nvPr/>
         </p:nvSpPr>
         <p:spPr>
           <a:xfrm>
-            <a:off x="384048" y="4453127"/>
-            <a:ext cx="5175504" cy="804672"/>
+            <a:off x="1481328" y="5102352"/>
+            <a:ext cx="896112" cy="292608"/>
           </a:xfrm>
           <a:prstGeom prst="roundRect">
             <a:avLst>
-              <a:gd name="adj" fmla="val 5500"/>
+              <a:gd name="adj" fmla="val 20000"/>
             </a:avLst>
           </a:prstGeom>
           <a:solidFill>
-            <a:srgbClr val="F6F8FB"/>
+            <a:srgbClr val="F2F4F7"/>
           </a:solidFill>
           <a:ln w="9525">
             <a:solidFill>
-              <a:srgbClr val="D9E0EA"/>
+              <a:srgbClr val="4A5568"/>
             </a:solidFill>
           </a:ln>
           <a:effectLst/>
@@ -4411,327 +5887,39 @@
           </a:fontRef>
         </p:style>
         <p:txBody>
-          <a:bodyPr rtlCol="0" anchor="ctr" wrap="square"/>
-          <a:lstStyle/>
-          <a:p>
-            <a:pPr algn="ctr"/>
-          </a:p>
-        </p:txBody>
-      </p:sp>
-      <p:sp>
-        <p:nvSpPr>
-          <p:cNvPr id="33" name="Rectangle 32"/>
-          <p:cNvSpPr/>
-          <p:nvPr/>
-        </p:nvSpPr>
-        <p:spPr>
-          <a:xfrm>
-            <a:off x="434340" y="4521707"/>
-            <a:ext cx="68580" cy="667512"/>
-          </a:xfrm>
-          <a:prstGeom prst="rect">
-            <a:avLst/>
-          </a:prstGeom>
-          <a:solidFill>
-            <a:srgbClr val="0F9B8E"/>
-          </a:solidFill>
-          <a:ln>
-            <a:noFill/>
-          </a:ln>
-          <a:effectLst/>
-        </p:spPr>
-        <p:style>
-          <a:lnRef idx="1">
-            <a:schemeClr val="accent1"/>
-          </a:lnRef>
-          <a:fillRef idx="3">
-            <a:schemeClr val="accent1"/>
-          </a:fillRef>
-          <a:effectRef idx="2">
-            <a:schemeClr val="accent1"/>
-          </a:effectRef>
-          <a:fontRef idx="minor">
-            <a:schemeClr val="lt1"/>
-          </a:fontRef>
-        </p:style>
-        <p:txBody>
-          <a:bodyPr rtlCol="0" anchor="ctr" wrap="square"/>
-          <a:lstStyle/>
-          <a:p>
-            <a:pPr algn="ctr"/>
-          </a:p>
-        </p:txBody>
-      </p:sp>
-      <p:sp>
-        <p:nvSpPr>
-          <p:cNvPr id="34" name="TextBox 33"/>
-          <p:cNvSpPr txBox="1"/>
-          <p:nvPr/>
-        </p:nvSpPr>
-        <p:spPr>
-          <a:xfrm>
-            <a:off x="603503" y="4544567"/>
-            <a:ext cx="4370831" cy="237744"/>
-          </a:xfrm>
-          <a:prstGeom prst="rect">
-            <a:avLst/>
-          </a:prstGeom>
-          <a:noFill/>
-        </p:spPr>
-        <p:txBody>
-          <a:bodyPr wrap="square" lIns="0" rIns="0" tIns="0" bIns="0" anchor="t">
-            <a:spAutoFit/>
-          </a:bodyPr>
-          <a:lstStyle/>
-          <a:p>
-            <a:pPr algn="l">
+          <a:bodyPr rtlCol="0" anchor="ctr" wrap="square" lIns="27432" rIns="27432" tIns="0" bIns="0"/>
+          <a:lstStyle/>
+          <a:p>
+            <a:pPr algn="ctr">
               <a:lnSpc>
-                <a:spcPct val="95000"/>
+                <a:spcPct val="105000"/>
               </a:lnSpc>
             </a:pPr>
             <a:r>
-              <a:rPr sz="1150" b="1">
+              <a:rPr sz="750" b="1">
                 <a:solidFill>
-                  <a:srgbClr val="14213D"/>
+                  <a:srgbClr val="4A5568"/>
                 </a:solidFill>
                 <a:latin typeface="Arial"/>
                 <a:ea typeface="微软雅黑"/>
               </a:rPr>
-              <a:t>④ 能力层 · 专家与专家团</a:t>
-            </a:r>
-          </a:p>
-        </p:txBody>
-      </p:sp>
-      <p:sp>
-        <p:nvSpPr>
-          <p:cNvPr id="35" name="Rounded Rectangle 34"/>
+              <a:t>CodeCheck</a:t>
+            </a:r>
+          </a:p>
+        </p:txBody>
+      </p:sp>
+      <p:sp>
+        <p:nvSpPr>
+          <p:cNvPr id="57" name="Right Arrow 56"/>
           <p:cNvSpPr/>
           <p:nvPr/>
         </p:nvSpPr>
         <p:spPr>
           <a:xfrm>
-            <a:off x="5029200" y="4558283"/>
-            <a:ext cx="402336" cy="196596"/>
-          </a:xfrm>
-          <a:prstGeom prst="roundRect">
-            <a:avLst>
-              <a:gd name="adj" fmla="val 28000"/>
-            </a:avLst>
-          </a:prstGeom>
-          <a:solidFill>
-            <a:srgbClr val="0F9B8E"/>
-          </a:solidFill>
-          <a:ln>
-            <a:noFill/>
-          </a:ln>
-          <a:effectLst/>
-        </p:spPr>
-        <p:style>
-          <a:lnRef idx="1">
-            <a:schemeClr val="accent1"/>
-          </a:lnRef>
-          <a:fillRef idx="3">
-            <a:schemeClr val="accent1"/>
-          </a:fillRef>
-          <a:effectRef idx="2">
-            <a:schemeClr val="accent1"/>
-          </a:effectRef>
-          <a:fontRef idx="minor">
-            <a:schemeClr val="lt1"/>
-          </a:fontRef>
-        </p:style>
-        <p:txBody>
-          <a:bodyPr rtlCol="0" anchor="ctr" wrap="square"/>
-          <a:lstStyle/>
-          <a:p>
-            <a:pPr algn="ctr"/>
-          </a:p>
-        </p:txBody>
-      </p:sp>
-      <p:sp>
-        <p:nvSpPr>
-          <p:cNvPr id="36" name="TextBox 35"/>
-          <p:cNvSpPr txBox="1"/>
-          <p:nvPr/>
-        </p:nvSpPr>
-        <p:spPr>
-          <a:xfrm>
-            <a:off x="5029200" y="4585715"/>
-            <a:ext cx="402336" cy="164592"/>
-          </a:xfrm>
-          <a:prstGeom prst="rect">
-            <a:avLst/>
-          </a:prstGeom>
-          <a:noFill/>
-        </p:spPr>
-        <p:txBody>
-          <a:bodyPr wrap="square" lIns="0" rIns="0" tIns="0" bIns="0" anchor="t">
-            <a:spAutoFit/>
-          </a:bodyPr>
-          <a:lstStyle/>
-          <a:p>
-            <a:pPr algn="ctr">
-              <a:lnSpc>
-                <a:spcPct val="95000"/>
-              </a:lnSpc>
-            </a:pPr>
-            <a:r>
-              <a:rPr sz="800" b="1">
-                <a:solidFill>
-                  <a:srgbClr val="FFFFFF"/>
-                </a:solidFill>
-                <a:latin typeface="Arial"/>
-                <a:ea typeface="微软雅黑"/>
-              </a:rPr>
-              <a:t>P0</a:t>
-            </a:r>
-          </a:p>
-        </p:txBody>
-      </p:sp>
-      <p:sp>
-        <p:nvSpPr>
-          <p:cNvPr id="37" name="TextBox 36"/>
-          <p:cNvSpPr txBox="1"/>
-          <p:nvPr/>
-        </p:nvSpPr>
-        <p:spPr>
-          <a:xfrm>
-            <a:off x="603503" y="4818888"/>
-            <a:ext cx="4754880" cy="384048"/>
-          </a:xfrm>
-          <a:prstGeom prst="rect">
-            <a:avLst/>
-          </a:prstGeom>
-          <a:noFill/>
-        </p:spPr>
-        <p:txBody>
-          <a:bodyPr wrap="square" lIns="0" rIns="0" tIns="0" bIns="0" anchor="t">
-            <a:spAutoFit/>
-          </a:bodyPr>
-          <a:lstStyle/>
-          <a:p>
-            <a:pPr algn="l">
-              <a:lnSpc>
-                <a:spcPct val="116000"/>
-              </a:lnSpc>
-            </a:pPr>
-            <a:r>
-              <a:rPr sz="850" b="0">
-                <a:solidFill>
-                  <a:srgbClr val="5A6678"/>
-                </a:solidFill>
-                <a:latin typeface="Arial"/>
-                <a:ea typeface="微软雅黑"/>
-              </a:rPr>
-              <a:t>Role Profile 契约（人设·方法论·工具·DoD·权限·模型档位）；场景专家团包：存量增量开发 / 鸿蒙适配 / 测试补齐 / 安全整改；专家市场与四级作用域治理</a:t>
-            </a:r>
-          </a:p>
-        </p:txBody>
-      </p:sp>
-      <p:sp>
-        <p:nvSpPr>
-          <p:cNvPr id="38" name="Isosceles Triangle 37"/>
-          <p:cNvSpPr/>
-          <p:nvPr/>
-        </p:nvSpPr>
-        <p:spPr>
-          <a:xfrm rot="10800000">
-            <a:off x="2843784" y="5266943"/>
-            <a:ext cx="256032" cy="137160"/>
-          </a:xfrm>
-          <a:prstGeom prst="triangle">
-            <a:avLst/>
-          </a:prstGeom>
-          <a:solidFill>
-            <a:srgbClr val="8C9AAD"/>
-          </a:solidFill>
-          <a:ln>
-            <a:noFill/>
-          </a:ln>
-          <a:effectLst/>
-        </p:spPr>
-        <p:style>
-          <a:lnRef idx="1">
-            <a:schemeClr val="accent1"/>
-          </a:lnRef>
-          <a:fillRef idx="3">
-            <a:schemeClr val="accent1"/>
-          </a:fillRef>
-          <a:effectRef idx="2">
-            <a:schemeClr val="accent1"/>
-          </a:effectRef>
-          <a:fontRef idx="minor">
-            <a:schemeClr val="lt1"/>
-          </a:fontRef>
-        </p:style>
-        <p:txBody>
-          <a:bodyPr rtlCol="0" anchor="ctr" wrap="square"/>
-          <a:lstStyle/>
-          <a:p>
-            <a:pPr algn="ctr"/>
-          </a:p>
-        </p:txBody>
-      </p:sp>
-      <p:sp>
-        <p:nvSpPr>
-          <p:cNvPr id="39" name="Rounded Rectangle 38"/>
-          <p:cNvSpPr/>
-          <p:nvPr/>
-        </p:nvSpPr>
-        <p:spPr>
-          <a:xfrm>
-            <a:off x="384048" y="5413247"/>
-            <a:ext cx="5175504" cy="804672"/>
-          </a:xfrm>
-          <a:prstGeom prst="roundRect">
-            <a:avLst>
-              <a:gd name="adj" fmla="val 5500"/>
-            </a:avLst>
-          </a:prstGeom>
-          <a:solidFill>
-            <a:srgbClr val="F6F8FB"/>
-          </a:solidFill>
-          <a:ln w="9525">
-            <a:solidFill>
-              <a:srgbClr val="D9E0EA"/>
-            </a:solidFill>
-          </a:ln>
-          <a:effectLst/>
-        </p:spPr>
-        <p:style>
-          <a:lnRef idx="1">
-            <a:schemeClr val="accent1"/>
-          </a:lnRef>
-          <a:fillRef idx="3">
-            <a:schemeClr val="accent1"/>
-          </a:fillRef>
-          <a:effectRef idx="2">
-            <a:schemeClr val="accent1"/>
-          </a:effectRef>
-          <a:fontRef idx="minor">
-            <a:schemeClr val="lt1"/>
-          </a:fontRef>
-        </p:style>
-        <p:txBody>
-          <a:bodyPr rtlCol="0" anchor="ctr" wrap="square"/>
-          <a:lstStyle/>
-          <a:p>
-            <a:pPr algn="ctr"/>
-          </a:p>
-        </p:txBody>
-      </p:sp>
-      <p:sp>
-        <p:nvSpPr>
-          <p:cNvPr id="40" name="Rectangle 39"/>
-          <p:cNvSpPr/>
-          <p:nvPr/>
-        </p:nvSpPr>
-        <p:spPr>
-          <a:xfrm>
-            <a:off x="434340" y="5481827"/>
-            <a:ext cx="68580" cy="667512"/>
-          </a:xfrm>
-          <a:prstGeom prst="rect">
+            <a:off x="2395728" y="5198364"/>
+            <a:ext cx="109728" cy="100584"/>
+          </a:xfrm>
+          <a:prstGeom prst="rightArrow">
             <a:avLst/>
           </a:prstGeom>
           <a:solidFill>
@@ -4766,59 +5954,79 @@
       </p:sp>
       <p:sp>
         <p:nvSpPr>
-          <p:cNvPr id="41" name="TextBox 40"/>
-          <p:cNvSpPr txBox="1"/>
+          <p:cNvPr id="58" name="Rounded Rectangle 57"/>
+          <p:cNvSpPr/>
           <p:nvPr/>
         </p:nvSpPr>
         <p:spPr>
           <a:xfrm>
-            <a:off x="603503" y="5504687"/>
-            <a:ext cx="4059935" cy="237744"/>
-          </a:xfrm>
-          <a:prstGeom prst="rect">
-            <a:avLst/>
+            <a:off x="2523744" y="5102352"/>
+            <a:ext cx="896112" cy="292608"/>
+          </a:xfrm>
+          <a:prstGeom prst="roundRect">
+            <a:avLst>
+              <a:gd name="adj" fmla="val 20000"/>
+            </a:avLst>
           </a:prstGeom>
-          <a:noFill/>
-        </p:spPr>
-        <p:txBody>
-          <a:bodyPr wrap="square" lIns="0" rIns="0" tIns="0" bIns="0" anchor="t">
-            <a:spAutoFit/>
-          </a:bodyPr>
-          <a:lstStyle/>
-          <a:p>
-            <a:pPr algn="l">
+          <a:solidFill>
+            <a:srgbClr val="F2F4F7"/>
+          </a:solidFill>
+          <a:ln w="9525">
+            <a:solidFill>
+              <a:srgbClr val="4A5568"/>
+            </a:solidFill>
+          </a:ln>
+          <a:effectLst/>
+        </p:spPr>
+        <p:style>
+          <a:lnRef idx="1">
+            <a:schemeClr val="accent1"/>
+          </a:lnRef>
+          <a:fillRef idx="3">
+            <a:schemeClr val="accent1"/>
+          </a:fillRef>
+          <a:effectRef idx="2">
+            <a:schemeClr val="accent1"/>
+          </a:effectRef>
+          <a:fontRef idx="minor">
+            <a:schemeClr val="lt1"/>
+          </a:fontRef>
+        </p:style>
+        <p:txBody>
+          <a:bodyPr rtlCol="0" anchor="ctr" wrap="square" lIns="27432" rIns="27432" tIns="0" bIns="0"/>
+          <a:lstStyle/>
+          <a:p>
+            <a:pPr algn="ctr">
               <a:lnSpc>
-                <a:spcPct val="95000"/>
+                <a:spcPct val="105000"/>
               </a:lnSpc>
             </a:pPr>
             <a:r>
-              <a:rPr sz="1150" b="1">
+              <a:rPr sz="750" b="1">
                 <a:solidFill>
-                  <a:srgbClr val="14213D"/>
+                  <a:srgbClr val="4A5568"/>
                 </a:solidFill>
                 <a:latin typeface="Arial"/>
                 <a:ea typeface="微软雅黑"/>
               </a:rPr>
-              <a:t>⑤ 底座 · Agent Team Ops</a:t>
-            </a:r>
-          </a:p>
-        </p:txBody>
-      </p:sp>
-      <p:sp>
-        <p:nvSpPr>
-          <p:cNvPr id="42" name="Rounded Rectangle 41"/>
+              <a:t>CloudTest</a:t>
+            </a:r>
+          </a:p>
+        </p:txBody>
+      </p:sp>
+      <p:sp>
+        <p:nvSpPr>
+          <p:cNvPr id="59" name="Right Arrow 58"/>
           <p:cNvSpPr/>
           <p:nvPr/>
         </p:nvSpPr>
         <p:spPr>
           <a:xfrm>
-            <a:off x="4718304" y="5518403"/>
-            <a:ext cx="713232" cy="196596"/>
-          </a:xfrm>
-          <a:prstGeom prst="roundRect">
-            <a:avLst>
-              <a:gd name="adj" fmla="val 28000"/>
-            </a:avLst>
+            <a:off x="3438144" y="5198364"/>
+            <a:ext cx="109728" cy="100584"/>
+          </a:xfrm>
+          <a:prstGeom prst="rightArrow">
+            <a:avLst/>
           </a:prstGeom>
           <a:solidFill>
             <a:srgbClr val="4A5568"/>
@@ -4852,14 +6060,403 @@
       </p:sp>
       <p:sp>
         <p:nvSpPr>
-          <p:cNvPr id="43" name="TextBox 42"/>
+          <p:cNvPr id="60" name="Rounded Rectangle 59"/>
+          <p:cNvSpPr/>
+          <p:nvPr/>
+        </p:nvSpPr>
+        <p:spPr>
+          <a:xfrm>
+            <a:off x="3566160" y="5102352"/>
+            <a:ext cx="896112" cy="292608"/>
+          </a:xfrm>
+          <a:prstGeom prst="roundRect">
+            <a:avLst>
+              <a:gd name="adj" fmla="val 20000"/>
+            </a:avLst>
+          </a:prstGeom>
+          <a:solidFill>
+            <a:srgbClr val="F2F4F7"/>
+          </a:solidFill>
+          <a:ln w="9525">
+            <a:solidFill>
+              <a:srgbClr val="4A5568"/>
+            </a:solidFill>
+          </a:ln>
+          <a:effectLst/>
+        </p:spPr>
+        <p:style>
+          <a:lnRef idx="1">
+            <a:schemeClr val="accent1"/>
+          </a:lnRef>
+          <a:fillRef idx="3">
+            <a:schemeClr val="accent1"/>
+          </a:fillRef>
+          <a:effectRef idx="2">
+            <a:schemeClr val="accent1"/>
+          </a:effectRef>
+          <a:fontRef idx="minor">
+            <a:schemeClr val="lt1"/>
+          </a:fontRef>
+        </p:style>
+        <p:txBody>
+          <a:bodyPr rtlCol="0" anchor="ctr" wrap="square" lIns="27432" rIns="27432" tIns="0" bIns="0"/>
+          <a:lstStyle/>
+          <a:p>
+            <a:pPr algn="ctr">
+              <a:lnSpc>
+                <a:spcPct val="105000"/>
+              </a:lnSpc>
+            </a:pPr>
+            <a:r>
+              <a:rPr sz="750" b="1">
+                <a:solidFill>
+                  <a:srgbClr val="4A5568"/>
+                </a:solidFill>
+                <a:latin typeface="Arial"/>
+                <a:ea typeface="微软雅黑"/>
+              </a:rPr>
+              <a:t>流水线门禁</a:t>
+            </a:r>
+          </a:p>
+        </p:txBody>
+      </p:sp>
+      <p:sp>
+        <p:nvSpPr>
+          <p:cNvPr id="61" name="Down Arrow 60"/>
+          <p:cNvSpPr/>
+          <p:nvPr/>
+        </p:nvSpPr>
+        <p:spPr>
+          <a:xfrm>
+            <a:off x="2903220" y="5413248"/>
+            <a:ext cx="137160" cy="128016"/>
+          </a:xfrm>
+          <a:prstGeom prst="downArrow">
+            <a:avLst/>
+          </a:prstGeom>
+          <a:solidFill>
+            <a:srgbClr val="6B7A90"/>
+          </a:solidFill>
+          <a:ln>
+            <a:noFill/>
+          </a:ln>
+          <a:effectLst/>
+        </p:spPr>
+        <p:style>
+          <a:lnRef idx="1">
+            <a:schemeClr val="accent1"/>
+          </a:lnRef>
+          <a:fillRef idx="3">
+            <a:schemeClr val="accent1"/>
+          </a:fillRef>
+          <a:effectRef idx="2">
+            <a:schemeClr val="accent1"/>
+          </a:effectRef>
+          <a:fontRef idx="minor">
+            <a:schemeClr val="lt1"/>
+          </a:fontRef>
+        </p:style>
+        <p:txBody>
+          <a:bodyPr rtlCol="0" anchor="ctr" wrap="square"/>
+          <a:lstStyle/>
+          <a:p>
+            <a:pPr algn="ctr"/>
+          </a:p>
+        </p:txBody>
+      </p:sp>
+      <p:sp>
+        <p:nvSpPr>
+          <p:cNvPr id="62" name="Rounded Rectangle 61"/>
+          <p:cNvSpPr/>
+          <p:nvPr/>
+        </p:nvSpPr>
+        <p:spPr>
+          <a:xfrm>
+            <a:off x="1755648" y="5559552"/>
+            <a:ext cx="2432304" cy="256032"/>
+          </a:xfrm>
+          <a:prstGeom prst="roundRect">
+            <a:avLst>
+              <a:gd name="adj" fmla="val 36000"/>
+            </a:avLst>
+          </a:prstGeom>
+          <a:solidFill>
+            <a:srgbClr val="FFFFFF"/>
+          </a:solidFill>
+          <a:ln w="9525">
+            <a:solidFill>
+              <a:srgbClr val="14213D"/>
+            </a:solidFill>
+          </a:ln>
+          <a:effectLst/>
+        </p:spPr>
+        <p:style>
+          <a:lnRef idx="1">
+            <a:schemeClr val="accent1"/>
+          </a:lnRef>
+          <a:fillRef idx="3">
+            <a:schemeClr val="accent1"/>
+          </a:fillRef>
+          <a:effectRef idx="2">
+            <a:schemeClr val="accent1"/>
+          </a:effectRef>
+          <a:fontRef idx="minor">
+            <a:schemeClr val="lt1"/>
+          </a:fontRef>
+        </p:style>
+        <p:txBody>
+          <a:bodyPr rtlCol="0" anchor="ctr" wrap="square" lIns="27432" rIns="27432" tIns="0" bIns="0"/>
+          <a:lstStyle/>
+          <a:p>
+            <a:pPr algn="ctr">
+              <a:lnSpc>
+                <a:spcPct val="105000"/>
+              </a:lnSpc>
+            </a:pPr>
+            <a:r>
+              <a:rPr sz="850" b="1">
+                <a:solidFill>
+                  <a:srgbClr val="14213D"/>
+                </a:solidFill>
+                <a:latin typeface="Arial"/>
+                <a:ea typeface="微软雅黑"/>
+              </a:rPr>
+              <a:t>⑤ 交付件 · PR · 任务报告 · 度量</a:t>
+            </a:r>
+          </a:p>
+        </p:txBody>
+      </p:sp>
+      <p:cxnSp>
+        <p:nvCxnSpPr>
+          <p:cNvPr id="63" name="Connector 62"/>
+          <p:cNvCxnSpPr/>
+          <p:nvPr/>
+        </p:nvCxnSpPr>
+        <p:spPr>
+          <a:xfrm>
+            <a:off x="1316736" y="2916936"/>
+            <a:ext cx="146303" cy="0"/>
+          </a:xfrm>
+          <a:prstGeom prst="line">
+            <a:avLst/>
+          </a:prstGeom>
+          <a:ln w="13970">
+            <a:solidFill>
+              <a:srgbClr val="0F9B8E"/>
+            </a:solidFill>
+            <a:prstDash val="sysDash"/>
+            <a:tailEnd type="triangle" w="sm" len="sm"/>
+          </a:ln>
+        </p:spPr>
+        <p:style>
+          <a:lnRef idx="2">
+            <a:schemeClr val="accent1"/>
+          </a:lnRef>
+          <a:fillRef idx="0">
+            <a:schemeClr val="accent1"/>
+          </a:fillRef>
+          <a:effectRef idx="1">
+            <a:schemeClr val="accent1"/>
+          </a:effectRef>
+          <a:fontRef idx="minor">
+            <a:schemeClr val="tx1"/>
+          </a:fontRef>
+        </p:style>
+      </p:cxnSp>
+      <p:cxnSp>
+        <p:nvCxnSpPr>
+          <p:cNvPr id="64" name="Connector 63"/>
+          <p:cNvCxnSpPr/>
+          <p:nvPr/>
+        </p:nvCxnSpPr>
+        <p:spPr>
+          <a:xfrm flipH="1">
+            <a:off x="4480559" y="2916936"/>
+            <a:ext cx="146305" cy="0"/>
+          </a:xfrm>
+          <a:prstGeom prst="line">
+            <a:avLst/>
+          </a:prstGeom>
+          <a:ln w="13970">
+            <a:solidFill>
+              <a:srgbClr val="4A5568"/>
+            </a:solidFill>
+            <a:prstDash val="sysDash"/>
+            <a:tailEnd type="triangle" w="sm" len="sm"/>
+          </a:ln>
+        </p:spPr>
+        <p:style>
+          <a:lnRef idx="2">
+            <a:schemeClr val="accent1"/>
+          </a:lnRef>
+          <a:fillRef idx="0">
+            <a:schemeClr val="accent1"/>
+          </a:fillRef>
+          <a:effectRef idx="1">
+            <a:schemeClr val="accent1"/>
+          </a:effectRef>
+          <a:fontRef idx="minor">
+            <a:schemeClr val="tx1"/>
+          </a:fontRef>
+        </p:style>
+      </p:cxnSp>
+      <p:cxnSp>
+        <p:nvCxnSpPr>
+          <p:cNvPr id="65" name="Connector 64"/>
+          <p:cNvCxnSpPr/>
+          <p:nvPr/>
+        </p:nvCxnSpPr>
+        <p:spPr>
+          <a:xfrm>
+            <a:off x="1316736" y="4480560"/>
+            <a:ext cx="146303" cy="0"/>
+          </a:xfrm>
+          <a:prstGeom prst="line">
+            <a:avLst/>
+          </a:prstGeom>
+          <a:ln w="13970">
+            <a:solidFill>
+              <a:srgbClr val="0F9B8E"/>
+            </a:solidFill>
+            <a:prstDash val="sysDash"/>
+            <a:tailEnd type="triangle" w="sm" len="sm"/>
+          </a:ln>
+        </p:spPr>
+        <p:style>
+          <a:lnRef idx="2">
+            <a:schemeClr val="accent1"/>
+          </a:lnRef>
+          <a:fillRef idx="0">
+            <a:schemeClr val="accent1"/>
+          </a:fillRef>
+          <a:effectRef idx="1">
+            <a:schemeClr val="accent1"/>
+          </a:effectRef>
+          <a:fontRef idx="minor">
+            <a:schemeClr val="tx1"/>
+          </a:fontRef>
+        </p:style>
+      </p:cxnSp>
+      <p:cxnSp>
+        <p:nvCxnSpPr>
+          <p:cNvPr id="66" name="Connector 65"/>
+          <p:cNvCxnSpPr/>
+          <p:nvPr/>
+        </p:nvCxnSpPr>
+        <p:spPr>
+          <a:xfrm flipH="1">
+            <a:off x="4480559" y="4480560"/>
+            <a:ext cx="146305" cy="0"/>
+          </a:xfrm>
+          <a:prstGeom prst="line">
+            <a:avLst/>
+          </a:prstGeom>
+          <a:ln w="13970">
+            <a:solidFill>
+              <a:srgbClr val="4A5568"/>
+            </a:solidFill>
+            <a:prstDash val="sysDash"/>
+            <a:tailEnd type="triangle" w="sm" len="sm"/>
+          </a:ln>
+        </p:spPr>
+        <p:style>
+          <a:lnRef idx="2">
+            <a:schemeClr val="accent1"/>
+          </a:lnRef>
+          <a:fillRef idx="0">
+            <a:schemeClr val="accent1"/>
+          </a:fillRef>
+          <a:effectRef idx="1">
+            <a:schemeClr val="accent1"/>
+          </a:effectRef>
+          <a:fontRef idx="minor">
+            <a:schemeClr val="tx1"/>
+          </a:fontRef>
+        </p:style>
+      </p:cxnSp>
+      <p:cxnSp>
+        <p:nvCxnSpPr>
+          <p:cNvPr id="67" name="Connector 66"/>
+          <p:cNvCxnSpPr/>
+          <p:nvPr/>
+        </p:nvCxnSpPr>
+        <p:spPr>
+          <a:xfrm flipH="1">
+            <a:off x="850392" y="5687568"/>
+            <a:ext cx="905256" cy="0"/>
+          </a:xfrm>
+          <a:prstGeom prst="line">
+            <a:avLst/>
+          </a:prstGeom>
+          <a:ln w="13970">
+            <a:solidFill>
+              <a:srgbClr val="94A3B8"/>
+            </a:solidFill>
+            <a:prstDash val="sysDash"/>
+          </a:ln>
+        </p:spPr>
+        <p:style>
+          <a:lnRef idx="2">
+            <a:schemeClr val="accent1"/>
+          </a:lnRef>
+          <a:fillRef idx="0">
+            <a:schemeClr val="accent1"/>
+          </a:fillRef>
+          <a:effectRef idx="1">
+            <a:schemeClr val="accent1"/>
+          </a:effectRef>
+          <a:fontRef idx="minor">
+            <a:schemeClr val="tx1"/>
+          </a:fontRef>
+        </p:style>
+      </p:cxnSp>
+      <p:cxnSp>
+        <p:nvCxnSpPr>
+          <p:cNvPr id="68" name="Connector 67"/>
+          <p:cNvCxnSpPr/>
+          <p:nvPr/>
+        </p:nvCxnSpPr>
+        <p:spPr>
+          <a:xfrm flipV="1">
+            <a:off x="850392" y="4956048"/>
+            <a:ext cx="0" cy="731520"/>
+          </a:xfrm>
+          <a:prstGeom prst="line">
+            <a:avLst/>
+          </a:prstGeom>
+          <a:ln w="13970">
+            <a:solidFill>
+              <a:srgbClr val="0F9B8E"/>
+            </a:solidFill>
+            <a:prstDash val="sysDash"/>
+            <a:tailEnd type="triangle" w="sm" len="sm"/>
+          </a:ln>
+        </p:spPr>
+        <p:style>
+          <a:lnRef idx="2">
+            <a:schemeClr val="accent1"/>
+          </a:lnRef>
+          <a:fillRef idx="0">
+            <a:schemeClr val="accent1"/>
+          </a:fillRef>
+          <a:effectRef idx="1">
+            <a:schemeClr val="accent1"/>
+          </a:effectRef>
+          <a:fontRef idx="minor">
+            <a:schemeClr val="tx1"/>
+          </a:fontRef>
+        </p:style>
+      </p:cxnSp>
+      <p:sp>
+        <p:nvSpPr>
+          <p:cNvPr id="69" name="TextBox 68"/>
           <p:cNvSpPr txBox="1"/>
           <p:nvPr/>
         </p:nvSpPr>
         <p:spPr>
           <a:xfrm>
-            <a:off x="4718304" y="5545835"/>
-            <a:ext cx="713232" cy="164592"/>
+            <a:off x="384048" y="5852160"/>
+            <a:ext cx="5175504" cy="146304"/>
           </a:xfrm>
           <a:prstGeom prst="rect">
             <a:avLst/>
@@ -4878,28 +6475,28 @@
               </a:lnSpc>
             </a:pPr>
             <a:r>
-              <a:rPr sz="800" b="1">
+              <a:rPr sz="700" b="0">
                 <a:solidFill>
-                  <a:srgbClr val="FFFFFF"/>
+                  <a:srgbClr val="0F9B8E"/>
                 </a:solidFill>
                 <a:latin typeface="Arial"/>
                 <a:ea typeface="微软雅黑"/>
               </a:rPr>
-              <a:t>P0 · P1</a:t>
-            </a:r>
-          </a:p>
-        </p:txBody>
-      </p:sp>
-      <p:sp>
-        <p:nvSpPr>
-          <p:cNvPr id="44" name="TextBox 43"/>
+              <a:t>轨迹回流：Trace → Blueprint 自动萃取 · 失败模式库 · 路由策略学习</a:t>
+            </a:r>
+          </a:p>
+        </p:txBody>
+      </p:sp>
+      <p:sp>
+        <p:nvSpPr>
+          <p:cNvPr id="70" name="TextBox 69"/>
           <p:cNvSpPr txBox="1"/>
           <p:nvPr/>
         </p:nvSpPr>
         <p:spPr>
           <a:xfrm>
-            <a:off x="603503" y="5779007"/>
-            <a:ext cx="4754880" cy="384048"/>
+            <a:off x="384048" y="6035040"/>
+            <a:ext cx="5175504" cy="146304"/>
           </a:xfrm>
           <a:prstGeom prst="rect">
             <a:avLst/>
@@ -4912,27 +6509,27 @@
           </a:bodyPr>
           <a:lstStyle/>
           <a:p>
-            <a:pPr algn="l">
+            <a:pPr algn="ctr">
               <a:lnSpc>
-                <a:spcPct val="116000"/>
+                <a:spcPct val="95000"/>
               </a:lnSpc>
             </a:pPr>
             <a:r>
-              <a:rPr sz="850" b="0">
+              <a:rPr sz="700" b="0">
                 <a:solidFill>
                   <a:srgbClr val="5A6678"/>
                 </a:solidFill>
                 <a:latin typeface="Arial"/>
                 <a:ea typeface="微软雅黑"/>
               </a:rPr>
-              <a:t>团队记忆与轨迹复盘 ｜ 单线程写入 + worktree 沙箱 ｜ 研发门禁 CodeCheck·CloudTest·流水线 ｜ 审计·配额·熔断 ｜ Codebase 与鸿蒙增训模型</a:t>
+              <a:t>实线＝任务执行主链路（①~⑤ P0 首版）　虚线＝资产 / 底座注入与反馈回环（P0 · P1 分批）</a:t>
             </a:r>
           </a:p>
         </p:txBody>
       </p:sp>
       <p:graphicFrame>
         <p:nvGraphicFramePr>
-          <p:cNvPr id="45" name="Table 44"/>
+          <p:cNvPr id="71" name="Table 70"/>
           <p:cNvGraphicFramePr>
             <a:graphicFrameLocks noGrp="1"/>
           </p:cNvGraphicFramePr>
@@ -5488,7 +7085,7 @@
       </p:graphicFrame>
       <p:sp>
         <p:nvSpPr>
-          <p:cNvPr id="46" name="Rectangle 45"/>
+          <p:cNvPr id="72" name="Rectangle 71"/>
           <p:cNvSpPr/>
           <p:nvPr/>
         </p:nvSpPr>
@@ -5532,7 +7129,7 @@
       </p:sp>
       <p:sp>
         <p:nvSpPr>
-          <p:cNvPr id="47" name="TextBox 46"/>
+          <p:cNvPr id="73" name="TextBox 72"/>
           <p:cNvSpPr txBox="1"/>
           <p:nvPr/>
         </p:nvSpPr>

</xml_diff>